<commit_message>
Deck: tighter v2 redesign
Bigger type, hard-cut copy, big stat callouts, mono data labels, gold
kicker motif. Drops "Featherless" naming (now "our own Algorand x402 AI
endpoint"). Fonts: Georgia / Calibri / Roboto Mono.

Co-Authored-By: Claude Opus 4.8 (1M context) <noreply@anthropic.com>
</commit_message>
<xml_diff>
--- a/docs/Sippar-Algorand-x402-Deck.pptx
+++ b/docs/Sippar-Algorand-x402-Deck.pptx
@@ -1328,8 +1328,8 @@
         </p:nvSpPr>
         <p:spPr>
           <a:xfrm>
-            <a:off x="640080" y="2011680"/>
-            <a:ext cx="10911535" cy="1005840"/>
+            <a:off x="777240" y="1371600"/>
+            <a:ext cx="10637215" cy="274320"/>
           </a:xfrm>
           <a:prstGeom prst="rect">
             <a:avLst/>
@@ -1345,7 +1345,46 @@
               <a:buNone/>
             </a:pPr>
             <a:r>
-              <a:rPr lang="en-US" sz="6000" b="1" spc="300" kern="0" dirty="0">
+              <a:rPr lang="en-US" sz="1200" spc="300" kern="0" dirty="0">
+                <a:solidFill>
+                  <a:srgbClr val="D49A53"/>
+                </a:solidFill>
+                <a:latin typeface="Roboto Mono" pitchFamily="34" charset="0"/>
+                <a:ea typeface="Roboto Mono" pitchFamily="34" charset="-122"/>
+                <a:cs typeface="Roboto Mono" pitchFamily="34" charset="-120"/>
+              </a:rPr>
+              <a:t>ALGORAND BUILDERS BERLIN  ·  AGENTIC COMMERCE x402</a:t>
+            </a:r>
+            <a:endParaRPr lang="en-US" sz="1200" dirty="0"/>
+          </a:p>
+        </p:txBody>
+      </p:sp>
+      <p:sp>
+        <p:nvSpPr>
+          <p:cNvPr id="3" name="Text 1"/>
+          <p:cNvSpPr/>
+          <p:nvPr/>
+        </p:nvSpPr>
+        <p:spPr>
+          <a:xfrm>
+            <a:off x="731520" y="2148840"/>
+            <a:ext cx="10637215" cy="1280160"/>
+          </a:xfrm>
+          <a:prstGeom prst="rect">
+            <a:avLst/>
+          </a:prstGeom>
+          <a:noFill/>
+          <a:ln/>
+        </p:spPr>
+        <p:txBody>
+          <a:bodyPr wrap="square" rtlCol="0" anchor="ctr"/>
+          <a:lstStyle/>
+          <a:p>
+            <a:pPr indent="0" marL="0">
+              <a:buNone/>
+            </a:pPr>
+            <a:r>
+              <a:rPr lang="en-US" sz="7200" b="1" dirty="0">
                 <a:solidFill>
                   <a:srgbClr val="D4A074"/>
                 </a:solidFill>
@@ -1353,22 +1392,22 @@
                 <a:ea typeface="Georgia" pitchFamily="34" charset="-122"/>
                 <a:cs typeface="Georgia" pitchFamily="34" charset="-120"/>
               </a:rPr>
-              <a:t>SIPPAR</a:t>
-            </a:r>
-            <a:endParaRPr lang="en-US" sz="6000" dirty="0"/>
-          </a:p>
-        </p:txBody>
-      </p:sp>
-      <p:sp>
-        <p:nvSpPr>
-          <p:cNvPr id="3" name="Text 1"/>
-          <p:cNvSpPr/>
-          <p:nvPr/>
-        </p:nvSpPr>
-        <p:spPr>
-          <a:xfrm>
-            <a:off x="640080" y="3154680"/>
-            <a:ext cx="10911535" cy="640080"/>
+              <a:t>Sippar</a:t>
+            </a:r>
+            <a:endParaRPr lang="en-US" sz="7200" dirty="0"/>
+          </a:p>
+        </p:txBody>
+      </p:sp>
+      <p:sp>
+        <p:nvSpPr>
+          <p:cNvPr id="4" name="Text 2"/>
+          <p:cNvSpPr/>
+          <p:nvPr/>
+        </p:nvSpPr>
+        <p:spPr>
+          <a:xfrm>
+            <a:off x="777240" y="3520440"/>
+            <a:ext cx="10637215" cy="640080"/>
           </a:xfrm>
           <a:prstGeom prst="rect">
             <a:avLst/>
@@ -1384,7 +1423,7 @@
               <a:buNone/>
             </a:pPr>
             <a:r>
-              <a:rPr lang="en-US" sz="2600" dirty="0">
+              <a:rPr lang="en-US" sz="2800" dirty="0">
                 <a:solidFill>
                   <a:srgbClr val="F4EFE6"/>
                 </a:solidFill>
@@ -1392,22 +1431,22 @@
                 <a:ea typeface="Georgia" pitchFamily="34" charset="-122"/>
                 <a:cs typeface="Georgia" pitchFamily="34" charset="-120"/>
               </a:rPr>
-              <a:t>The trust root for the agent economy</a:t>
-            </a:r>
-            <a:endParaRPr lang="en-US" sz="2600" dirty="0"/>
-          </a:p>
-        </p:txBody>
-      </p:sp>
-      <p:sp>
-        <p:nvSpPr>
-          <p:cNvPr id="4" name="Text 2"/>
-          <p:cNvSpPr/>
-          <p:nvPr/>
-        </p:nvSpPr>
-        <p:spPr>
-          <a:xfrm>
-            <a:off x="640080" y="3886200"/>
-            <a:ext cx="10911535" cy="822960"/>
+              <a:t>The trust root for the agent economy.</a:t>
+            </a:r>
+            <a:endParaRPr lang="en-US" sz="2800" dirty="0"/>
+          </a:p>
+        </p:txBody>
+      </p:sp>
+      <p:sp>
+        <p:nvSpPr>
+          <p:cNvPr id="5" name="Text 3"/>
+          <p:cNvSpPr/>
+          <p:nvPr/>
+        </p:nvSpPr>
+        <p:spPr>
+          <a:xfrm>
+            <a:off x="777240" y="4251960"/>
+            <a:ext cx="10637215" cy="457200"/>
           </a:xfrm>
           <a:prstGeom prst="rect">
             <a:avLst/>
@@ -1420,13 +1459,10 @@
           <a:lstStyle/>
           <a:p>
             <a:pPr indent="0" marL="0">
-              <a:lnSpc>
-                <a:spcPct val="120000"/>
-              </a:lnSpc>
               <a:buNone/>
             </a:pPr>
             <a:r>
-              <a:rPr lang="en-US" sz="1500" dirty="0">
+              <a:rPr lang="en-US" sz="1600" dirty="0">
                 <a:solidFill>
                   <a:srgbClr val="94A0B8"/>
                 </a:solidFill>
@@ -1434,42 +1470,22 @@
                 <a:ea typeface="Calibri" pitchFamily="34" charset="-122"/>
                 <a:cs typeface="Calibri" pitchFamily="34" charset="-120"/>
               </a:rPr>
-              <a:t>Pay any Algorand x402 service from any chain — via ICP threshold signatures.</a:t>
-            </a:r>
-            <a:endParaRPr lang="en-US" sz="1500" dirty="0"/>
-          </a:p>
-          <a:p>
-            <a:pPr indent="0" marL="0">
-              <a:lnSpc>
-                <a:spcPct val="120000"/>
-              </a:lnSpc>
-              <a:buNone/>
-            </a:pPr>
-            <a:r>
-              <a:rPr lang="en-US" sz="1500" dirty="0">
-                <a:solidFill>
-                  <a:srgbClr val="94A0B8"/>
-                </a:solidFill>
-                <a:latin typeface="Calibri" pitchFamily="34" charset="0"/>
-                <a:ea typeface="Calibri" pitchFamily="34" charset="-122"/>
-                <a:cs typeface="Calibri" pitchFamily="34" charset="-120"/>
-              </a:rPr>
-              <a:t>No bridge. No custodian. No seed phrase.</a:t>
-            </a:r>
-            <a:endParaRPr lang="en-US" sz="1500" dirty="0"/>
-          </a:p>
-        </p:txBody>
-      </p:sp>
-      <p:sp>
-        <p:nvSpPr>
-          <p:cNvPr id="5" name="Text 3"/>
-          <p:cNvSpPr/>
-          <p:nvPr/>
-        </p:nvSpPr>
-        <p:spPr>
-          <a:xfrm>
-            <a:off x="640080" y="6126480"/>
-            <a:ext cx="10911535" cy="365760"/>
+              <a:t>Any agent, any chain — pays Algorand x402 services via ICP threshold signatures.</a:t>
+            </a:r>
+            <a:endParaRPr lang="en-US" sz="1600" dirty="0"/>
+          </a:p>
+        </p:txBody>
+      </p:sp>
+      <p:sp>
+        <p:nvSpPr>
+          <p:cNvPr id="6" name="Text 4"/>
+          <p:cNvSpPr/>
+          <p:nvPr/>
+        </p:nvSpPr>
+        <p:spPr>
+          <a:xfrm>
+            <a:off x="777240" y="6035040"/>
+            <a:ext cx="10637215" cy="320040"/>
           </a:xfrm>
           <a:prstGeom prst="rect">
             <a:avLst/>
@@ -1485,17 +1501,17 @@
               <a:buNone/>
             </a:pPr>
             <a:r>
-              <a:rPr lang="en-US" sz="1200" dirty="0">
+              <a:rPr lang="en-US" sz="1100" spc="100" kern="0" dirty="0">
                 <a:solidFill>
                   <a:srgbClr val="D49A53"/>
                 </a:solidFill>
-                <a:latin typeface="Calibri" pitchFamily="34" charset="0"/>
-                <a:ea typeface="Calibri" pitchFamily="34" charset="-122"/>
-                <a:cs typeface="Calibri" pitchFamily="34" charset="-120"/>
-              </a:rPr>
-              <a:t>Algorand Builders Berlin  ·  Agentic Commerce x402  ·  Track 1 (Existing Project)  ·  Quantoz EURQ bonus</a:t>
-            </a:r>
-            <a:endParaRPr lang="en-US" sz="1200" dirty="0"/>
+                <a:latin typeface="Roboto Mono" pitchFamily="34" charset="0"/>
+                <a:ea typeface="Roboto Mono" pitchFamily="34" charset="-122"/>
+                <a:cs typeface="Roboto Mono" pitchFamily="34" charset="-120"/>
+              </a:rPr>
+              <a:t>Track 1 · Existing Project          ◆          Quantoz EURQ bonus</a:t>
+            </a:r>
+            <a:endParaRPr lang="en-US" sz="1100" dirty="0"/>
           </a:p>
         </p:txBody>
       </p:sp>
@@ -1539,8 +1555,8 @@
         </p:nvSpPr>
         <p:spPr>
           <a:xfrm>
-            <a:off x="640080" y="502920"/>
-            <a:ext cx="10911535" cy="274320"/>
+            <a:off x="11277295" y="6355080"/>
+            <a:ext cx="548640" cy="274320"/>
           </a:xfrm>
           <a:prstGeom prst="rect">
             <a:avLst/>
@@ -1552,34 +1568,209 @@
           <a:bodyPr wrap="square" rtlCol="0" anchor="ctr"/>
           <a:lstStyle/>
           <a:p>
+            <a:pPr algn="r" indent="0" marL="0">
+              <a:buNone/>
+            </a:pPr>
+            <a:r>
+              <a:rPr lang="en-US" sz="900" dirty="0">
+                <a:solidFill>
+                  <a:srgbClr val="94A0B8"/>
+                </a:solidFill>
+                <a:latin typeface="Roboto Mono" pitchFamily="34" charset="0"/>
+                <a:ea typeface="Roboto Mono" pitchFamily="34" charset="-122"/>
+                <a:cs typeface="Roboto Mono" pitchFamily="34" charset="-120"/>
+              </a:rPr>
+              <a:t>02</a:t>
+            </a:r>
+            <a:endParaRPr lang="en-US" sz="900" dirty="0"/>
+          </a:p>
+        </p:txBody>
+      </p:sp>
+      <p:sp>
+        <p:nvSpPr>
+          <p:cNvPr id="3" name="Text 1"/>
+          <p:cNvSpPr/>
+          <p:nvPr/>
+        </p:nvSpPr>
+        <p:spPr>
+          <a:xfrm>
+            <a:off x="777240" y="566928"/>
+            <a:ext cx="10637215" cy="274320"/>
+          </a:xfrm>
+          <a:prstGeom prst="rect">
+            <a:avLst/>
+          </a:prstGeom>
+          <a:noFill/>
+          <a:ln/>
+        </p:spPr>
+        <p:txBody>
+          <a:bodyPr wrap="square" rtlCol="0" anchor="ctr"/>
+          <a:lstStyle/>
+          <a:p>
             <a:pPr indent="0" marL="0">
               <a:buNone/>
             </a:pPr>
             <a:r>
-              <a:rPr lang="en-US" sz="1200" b="1" spc="200" kern="0" dirty="0">
+              <a:rPr lang="en-US" sz="1100" spc="300" kern="0" dirty="0">
                 <a:solidFill>
                   <a:srgbClr val="D49A53"/>
+                </a:solidFill>
+                <a:latin typeface="Roboto Mono" pitchFamily="34" charset="0"/>
+                <a:ea typeface="Roboto Mono" pitchFamily="34" charset="-122"/>
+                <a:cs typeface="Roboto Mono" pitchFamily="34" charset="-120"/>
+              </a:rPr>
+              <a:t>THE BUYER CHANGED</a:t>
+            </a:r>
+            <a:endParaRPr lang="en-US" sz="1100" dirty="0"/>
+          </a:p>
+        </p:txBody>
+      </p:sp>
+      <p:sp>
+        <p:nvSpPr>
+          <p:cNvPr id="4" name="Text 2"/>
+          <p:cNvSpPr/>
+          <p:nvPr/>
+        </p:nvSpPr>
+        <p:spPr>
+          <a:xfrm>
+            <a:off x="777240" y="960120"/>
+            <a:ext cx="10637215" cy="868680"/>
+          </a:xfrm>
+          <a:prstGeom prst="rect">
+            <a:avLst/>
+          </a:prstGeom>
+          <a:noFill/>
+          <a:ln/>
+        </p:spPr>
+        <p:txBody>
+          <a:bodyPr wrap="square" rtlCol="0" anchor="ctr"/>
+          <a:lstStyle/>
+          <a:p>
+            <a:pPr indent="0" marL="0">
+              <a:buNone/>
+            </a:pPr>
+            <a:r>
+              <a:rPr lang="en-US" sz="3200" b="1" dirty="0">
+                <a:solidFill>
+                  <a:srgbClr val="F4EFE6"/>
+                </a:solidFill>
+                <a:latin typeface="Georgia" pitchFamily="34" charset="0"/>
+                <a:ea typeface="Georgia" pitchFamily="34" charset="-122"/>
+                <a:cs typeface="Georgia" pitchFamily="34" charset="-120"/>
+              </a:rPr>
+              <a:t>Micropayments aren't new. The approver is.</a:t>
+            </a:r>
+            <a:endParaRPr lang="en-US" sz="3200" dirty="0"/>
+          </a:p>
+        </p:txBody>
+      </p:sp>
+      <p:sp>
+        <p:nvSpPr>
+          <p:cNvPr id="5" name="Text 3"/>
+          <p:cNvSpPr/>
+          <p:nvPr/>
+        </p:nvSpPr>
+        <p:spPr>
+          <a:xfrm>
+            <a:off x="777240" y="2011680"/>
+            <a:ext cx="10637215" cy="1463040"/>
+          </a:xfrm>
+          <a:prstGeom prst="rect">
+            <a:avLst/>
+          </a:prstGeom>
+          <a:noFill/>
+          <a:ln/>
+        </p:spPr>
+        <p:txBody>
+          <a:bodyPr wrap="square" rtlCol="0" anchor="ctr"/>
+          <a:lstStyle/>
+          <a:p>
+            <a:pPr marL="228600" indent="-228600">
+              <a:lnSpc>
+                <a:spcPct val="110000"/>
+              </a:lnSpc>
+              <a:spcAft>
+                <a:spcPts val="1400"/>
+              </a:spcAft>
+              <a:buSzPct val="100000"/>
+              <a:buChar char="◆"/>
+            </a:pPr>
+            <a:r>
+              <a:rPr lang="en-US" sz="1700" dirty="0">
+                <a:solidFill>
+                  <a:srgbClr val="F4EFE6"/>
                 </a:solidFill>
                 <a:latin typeface="Calibri" pitchFamily="34" charset="0"/>
                 <a:ea typeface="Calibri" pitchFamily="34" charset="-122"/>
                 <a:cs typeface="Calibri" pitchFamily="34" charset="-120"/>
               </a:rPr>
-              <a:t>THE BUYER CHANGED</a:t>
-            </a:r>
-            <a:endParaRPr lang="en-US" sz="1200" dirty="0"/>
-          </a:p>
-        </p:txBody>
-      </p:sp>
-      <p:sp>
-        <p:nvSpPr>
-          <p:cNvPr id="3" name="Text 1"/>
-          <p:cNvSpPr/>
-          <p:nvPr/>
-        </p:nvSpPr>
-        <p:spPr>
-          <a:xfrm>
-            <a:off x="640080" y="868680"/>
-            <a:ext cx="10911535" cy="914400"/>
+              <a:t>HTTP 402 “Payment Required” sat empty for ~30 years.</a:t>
+            </a:r>
+            <a:endParaRPr lang="en-US" sz="1700" dirty="0"/>
+          </a:p>
+          <a:p>
+            <a:pPr marL="228600" indent="-228600">
+              <a:lnSpc>
+                <a:spcPct val="110000"/>
+              </a:lnSpc>
+              <a:spcAft>
+                <a:spcPts val="1400"/>
+              </a:spcAft>
+              <a:buSzPct val="100000"/>
+              <a:buChar char="◆"/>
+            </a:pPr>
+            <a:r>
+              <a:rPr lang="en-US" sz="1700" dirty="0">
+                <a:solidFill>
+                  <a:srgbClr val="F4EFE6"/>
+                </a:solidFill>
+                <a:latin typeface="Calibri" pitchFamily="34" charset="0"/>
+                <a:ea typeface="Calibri" pitchFamily="34" charset="-122"/>
+                <a:cs typeface="Calibri" pitchFamily="34" charset="-120"/>
+              </a:rPr>
+              <a:t>In 12 months three walls fell: fee floors died, software got hands, payment giants shipped agent protocols.</a:t>
+            </a:r>
+            <a:endParaRPr lang="en-US" sz="1700" dirty="0"/>
+          </a:p>
+        </p:txBody>
+      </p:sp>
+      <p:sp>
+        <p:nvSpPr>
+          <p:cNvPr id="6" name="Shape 4"/>
+          <p:cNvSpPr/>
+          <p:nvPr/>
+        </p:nvSpPr>
+        <p:spPr>
+          <a:xfrm>
+            <a:off x="777240" y="3977640"/>
+            <a:ext cx="3332378" cy="1417320"/>
+          </a:xfrm>
+          <a:prstGeom prst="roundRect">
+            <a:avLst>
+              <a:gd name="adj" fmla="val 4516"/>
+            </a:avLst>
+          </a:prstGeom>
+          <a:solidFill>
+            <a:srgbClr val="0E1A38"/>
+          </a:solidFill>
+          <a:ln w="12700">
+            <a:solidFill>
+              <a:srgbClr val="142140"/>
+            </a:solidFill>
+            <a:prstDash val="solid"/>
+          </a:ln>
+        </p:spPr>
+      </p:sp>
+      <p:sp>
+        <p:nvSpPr>
+          <p:cNvPr id="7" name="Text 5"/>
+          <p:cNvSpPr/>
+          <p:nvPr/>
+        </p:nvSpPr>
+        <p:spPr>
+          <a:xfrm>
+            <a:off x="777240" y="4114800"/>
+            <a:ext cx="3332378" cy="731520"/>
           </a:xfrm>
           <a:prstGeom prst="rect">
             <a:avLst/>
@@ -1591,57 +1782,139 @@
           <a:bodyPr wrap="square" rtlCol="0" anchor="ctr"/>
           <a:lstStyle/>
           <a:p>
-            <a:pPr indent="0" marL="0">
-              <a:lnSpc>
-                <a:spcPct val="100000"/>
-              </a:lnSpc>
+            <a:pPr algn="ctr" indent="0" marL="0">
               <a:buNone/>
             </a:pPr>
             <a:r>
-              <a:rPr lang="en-US" sz="3200" b="1" dirty="0">
-                <a:solidFill>
-                  <a:srgbClr val="F4EFE6"/>
+              <a:rPr lang="en-US" sz="4000" b="1" dirty="0">
+                <a:solidFill>
+                  <a:srgbClr val="D4A074"/>
                 </a:solidFill>
                 <a:latin typeface="Georgia" pitchFamily="34" charset="0"/>
                 <a:ea typeface="Georgia" pitchFamily="34" charset="-122"/>
                 <a:cs typeface="Georgia" pitchFamily="34" charset="-120"/>
               </a:rPr>
-              <a:t>Micropayments aren't new.</a:t>
-            </a:r>
-            <a:endParaRPr lang="en-US" sz="3200" dirty="0"/>
-          </a:p>
-          <a:p>
-            <a:pPr indent="0" marL="0">
-              <a:lnSpc>
-                <a:spcPct val="100000"/>
-              </a:lnSpc>
+              <a:t>$33T</a:t>
+            </a:r>
+            <a:endParaRPr lang="en-US" sz="4000" dirty="0"/>
+          </a:p>
+        </p:txBody>
+      </p:sp>
+      <p:sp>
+        <p:nvSpPr>
+          <p:cNvPr id="8" name="Text 6"/>
+          <p:cNvSpPr/>
+          <p:nvPr/>
+        </p:nvSpPr>
+        <p:spPr>
+          <a:xfrm>
+            <a:off x="914400" y="4892040"/>
+            <a:ext cx="3058058" cy="457200"/>
+          </a:xfrm>
+          <a:prstGeom prst="rect">
+            <a:avLst/>
+          </a:prstGeom>
+          <a:noFill/>
+          <a:ln/>
+        </p:spPr>
+        <p:txBody>
+          <a:bodyPr wrap="square" rtlCol="0" anchor="ctr"/>
+          <a:lstStyle/>
+          <a:p>
+            <a:pPr algn="ctr" indent="0" marL="0">
               <a:buNone/>
             </a:pPr>
             <a:r>
-              <a:rPr lang="en-US" sz="3200" b="1" dirty="0">
-                <a:solidFill>
-                  <a:srgbClr val="F4EFE6"/>
+              <a:rPr lang="en-US" sz="1150" dirty="0">
+                <a:solidFill>
+                  <a:srgbClr val="94A0B8"/>
+                </a:solidFill>
+                <a:latin typeface="Calibri" pitchFamily="34" charset="0"/>
+                <a:ea typeface="Calibri" pitchFamily="34" charset="-122"/>
+                <a:cs typeface="Calibri" pitchFamily="34" charset="-120"/>
+              </a:rPr>
+              <a:t>stablecoin volume 2025 — past Visa</a:t>
+            </a:r>
+            <a:endParaRPr lang="en-US" sz="1150" dirty="0"/>
+          </a:p>
+        </p:txBody>
+      </p:sp>
+      <p:sp>
+        <p:nvSpPr>
+          <p:cNvPr id="9" name="Shape 7"/>
+          <p:cNvSpPr/>
+          <p:nvPr/>
+        </p:nvSpPr>
+        <p:spPr>
+          <a:xfrm>
+            <a:off x="4429658" y="3977640"/>
+            <a:ext cx="3332378" cy="1417320"/>
+          </a:xfrm>
+          <a:prstGeom prst="roundRect">
+            <a:avLst>
+              <a:gd name="adj" fmla="val 4516"/>
+            </a:avLst>
+          </a:prstGeom>
+          <a:solidFill>
+            <a:srgbClr val="0E1A38"/>
+          </a:solidFill>
+          <a:ln w="12700">
+            <a:solidFill>
+              <a:srgbClr val="142140"/>
+            </a:solidFill>
+            <a:prstDash val="solid"/>
+          </a:ln>
+        </p:spPr>
+      </p:sp>
+      <p:sp>
+        <p:nvSpPr>
+          <p:cNvPr id="10" name="Text 8"/>
+          <p:cNvSpPr/>
+          <p:nvPr/>
+        </p:nvSpPr>
+        <p:spPr>
+          <a:xfrm>
+            <a:off x="4429658" y="4114800"/>
+            <a:ext cx="3332378" cy="731520"/>
+          </a:xfrm>
+          <a:prstGeom prst="rect">
+            <a:avLst/>
+          </a:prstGeom>
+          <a:noFill/>
+          <a:ln/>
+        </p:spPr>
+        <p:txBody>
+          <a:bodyPr wrap="square" rtlCol="0" anchor="ctr"/>
+          <a:lstStyle/>
+          <a:p>
+            <a:pPr algn="ctr" indent="0" marL="0">
+              <a:buNone/>
+            </a:pPr>
+            <a:r>
+              <a:rPr lang="en-US" sz="4000" b="1" dirty="0">
+                <a:solidFill>
+                  <a:srgbClr val="D4A074"/>
                 </a:solidFill>
                 <a:latin typeface="Georgia" pitchFamily="34" charset="0"/>
                 <a:ea typeface="Georgia" pitchFamily="34" charset="-122"/>
                 <a:cs typeface="Georgia" pitchFamily="34" charset="-120"/>
               </a:rPr>
-              <a:t>The thing that approves them is.</a:t>
-            </a:r>
-            <a:endParaRPr lang="en-US" sz="3200" dirty="0"/>
-          </a:p>
-        </p:txBody>
-      </p:sp>
-      <p:sp>
-        <p:nvSpPr>
-          <p:cNvPr id="4" name="Text 2"/>
-          <p:cNvSpPr/>
-          <p:nvPr/>
-        </p:nvSpPr>
-        <p:spPr>
-          <a:xfrm>
-            <a:off x="640080" y="2331720"/>
-            <a:ext cx="10911535" cy="1463040"/>
+              <a:t>$3–5T</a:t>
+            </a:r>
+            <a:endParaRPr lang="en-US" sz="4000" dirty="0"/>
+          </a:p>
+        </p:txBody>
+      </p:sp>
+      <p:sp>
+        <p:nvSpPr>
+          <p:cNvPr id="11" name="Text 9"/>
+          <p:cNvSpPr/>
+          <p:nvPr/>
+        </p:nvSpPr>
+        <p:spPr>
+          <a:xfrm>
+            <a:off x="4566818" y="4892040"/>
+            <a:ext cx="3058058" cy="457200"/>
           </a:xfrm>
           <a:prstGeom prst="rect">
             <a:avLst/>
@@ -1653,116 +1926,139 @@
           <a:bodyPr wrap="square" rtlCol="0" anchor="ctr"/>
           <a:lstStyle/>
           <a:p>
-            <a:pPr marL="342900" indent="-342900">
-              <a:lnSpc>
-                <a:spcPct val="115000"/>
-              </a:lnSpc>
-              <a:spcAft>
-                <a:spcPts val="800"/>
-              </a:spcAft>
-              <a:buSzPct val="100000"/>
-              <a:buChar char="•"/>
-            </a:pPr>
-            <a:r>
-              <a:rPr lang="en-US" sz="1600" dirty="0">
-                <a:solidFill>
-                  <a:srgbClr val="F4EFE6"/>
+            <a:pPr algn="ctr" indent="0" marL="0">
+              <a:buNone/>
+            </a:pPr>
+            <a:r>
+              <a:rPr lang="en-US" sz="1150" dirty="0">
+                <a:solidFill>
+                  <a:srgbClr val="94A0B8"/>
                 </a:solidFill>
                 <a:latin typeface="Calibri" pitchFamily="34" charset="0"/>
                 <a:ea typeface="Calibri" pitchFamily="34" charset="-122"/>
                 <a:cs typeface="Calibri" pitchFamily="34" charset="-120"/>
               </a:rPr>
-              <a:t>HTTP 402 “Payment Required” sat empty in every browser for ~30 years.</a:t>
-            </a:r>
-            <a:endParaRPr lang="en-US" sz="1600" dirty="0"/>
-          </a:p>
-          <a:p>
-            <a:pPr marL="342900" indent="-342900">
-              <a:lnSpc>
-                <a:spcPct val="115000"/>
-              </a:lnSpc>
-              <a:spcAft>
-                <a:spcPts val="800"/>
-              </a:spcAft>
-              <a:buSzPct val="100000"/>
-              <a:buChar char="•"/>
-            </a:pPr>
-            <a:r>
-              <a:rPr lang="en-US" sz="1600" dirty="0">
-                <a:solidFill>
-                  <a:srgbClr val="F4EFE6"/>
+              <a:t>agent commerce by 2030 · McKinsey</a:t>
+            </a:r>
+            <a:endParaRPr lang="en-US" sz="1150" dirty="0"/>
+          </a:p>
+        </p:txBody>
+      </p:sp>
+      <p:sp>
+        <p:nvSpPr>
+          <p:cNvPr id="12" name="Shape 10"/>
+          <p:cNvSpPr/>
+          <p:nvPr/>
+        </p:nvSpPr>
+        <p:spPr>
+          <a:xfrm>
+            <a:off x="8082077" y="3977640"/>
+            <a:ext cx="3332378" cy="1417320"/>
+          </a:xfrm>
+          <a:prstGeom prst="roundRect">
+            <a:avLst>
+              <a:gd name="adj" fmla="val 4516"/>
+            </a:avLst>
+          </a:prstGeom>
+          <a:solidFill>
+            <a:srgbClr val="0E1A38"/>
+          </a:solidFill>
+          <a:ln w="12700">
+            <a:solidFill>
+              <a:srgbClr val="142140"/>
+            </a:solidFill>
+            <a:prstDash val="solid"/>
+          </a:ln>
+        </p:spPr>
+      </p:sp>
+      <p:sp>
+        <p:nvSpPr>
+          <p:cNvPr id="13" name="Text 11"/>
+          <p:cNvSpPr/>
+          <p:nvPr/>
+        </p:nvSpPr>
+        <p:spPr>
+          <a:xfrm>
+            <a:off x="8082077" y="4114800"/>
+            <a:ext cx="3332378" cy="731520"/>
+          </a:xfrm>
+          <a:prstGeom prst="rect">
+            <a:avLst/>
+          </a:prstGeom>
+          <a:noFill/>
+          <a:ln/>
+        </p:spPr>
+        <p:txBody>
+          <a:bodyPr wrap="square" rtlCol="0" anchor="ctr"/>
+          <a:lstStyle/>
+          <a:p>
+            <a:pPr algn="ctr" indent="0" marL="0">
+              <a:buNone/>
+            </a:pPr>
+            <a:r>
+              <a:rPr lang="en-US" sz="4000" b="1" dirty="0">
+                <a:solidFill>
+                  <a:srgbClr val="D4A074"/>
+                </a:solidFill>
+                <a:latin typeface="Georgia" pitchFamily="34" charset="0"/>
+                <a:ea typeface="Georgia" pitchFamily="34" charset="-122"/>
+                <a:cs typeface="Georgia" pitchFamily="34" charset="-120"/>
+              </a:rPr>
+              <a:t>$15T</a:t>
+            </a:r>
+            <a:endParaRPr lang="en-US" sz="4000" dirty="0"/>
+          </a:p>
+        </p:txBody>
+      </p:sp>
+      <p:sp>
+        <p:nvSpPr>
+          <p:cNvPr id="14" name="Text 12"/>
+          <p:cNvSpPr/>
+          <p:nvPr/>
+        </p:nvSpPr>
+        <p:spPr>
+          <a:xfrm>
+            <a:off x="8219237" y="4892040"/>
+            <a:ext cx="3058058" cy="457200"/>
+          </a:xfrm>
+          <a:prstGeom prst="rect">
+            <a:avLst/>
+          </a:prstGeom>
+          <a:noFill/>
+          <a:ln/>
+        </p:spPr>
+        <p:txBody>
+          <a:bodyPr wrap="square" rtlCol="0" anchor="ctr"/>
+          <a:lstStyle/>
+          <a:p>
+            <a:pPr algn="ctr" indent="0" marL="0">
+              <a:buNone/>
+            </a:pPr>
+            <a:r>
+              <a:rPr lang="en-US" sz="1150" dirty="0">
+                <a:solidFill>
+                  <a:srgbClr val="94A0B8"/>
                 </a:solidFill>
                 <a:latin typeface="Calibri" pitchFamily="34" charset="0"/>
                 <a:ea typeface="Calibri" pitchFamily="34" charset="-122"/>
                 <a:cs typeface="Calibri" pitchFamily="34" charset="-120"/>
               </a:rPr>
-              <a:t>In 12 months three walls fell at once: card fee floors died, software got hands, and every payment giant shipped an agent protocol.</a:t>
-            </a:r>
-            <a:endParaRPr lang="en-US" sz="1600" dirty="0"/>
-          </a:p>
-          <a:p>
-            <a:pPr marL="342900" indent="-342900">
-              <a:lnSpc>
-                <a:spcPct val="115000"/>
-              </a:lnSpc>
-              <a:spcAft>
-                <a:spcPts val="800"/>
-              </a:spcAft>
-              <a:buSzPct val="100000"/>
-              <a:buChar char="•"/>
-            </a:pPr>
-            <a:r>
-              <a:rPr lang="en-US" sz="1600" dirty="0">
-                <a:solidFill>
-                  <a:srgbClr val="F4EFE6"/>
-                </a:solidFill>
-                <a:latin typeface="Calibri" pitchFamily="34" charset="0"/>
-                <a:ea typeface="Calibri" pitchFamily="34" charset="-122"/>
-                <a:cs typeface="Calibri" pitchFamily="34" charset="-120"/>
-              </a:rPr>
-              <a:t>Now a fact can cost three sips. The unit is the inference-call. 1 sip = $0.0001.</a:t>
-            </a:r>
-            <a:endParaRPr lang="en-US" sz="1600" dirty="0"/>
-          </a:p>
-        </p:txBody>
-      </p:sp>
-      <p:sp>
-        <p:nvSpPr>
-          <p:cNvPr id="5" name="Shape 3"/>
-          <p:cNvSpPr/>
-          <p:nvPr/>
-        </p:nvSpPr>
-        <p:spPr>
-          <a:xfrm>
-            <a:off x="640080" y="4114800"/>
-            <a:ext cx="3454298" cy="1554480"/>
-          </a:xfrm>
-          <a:prstGeom prst="roundRect">
-            <a:avLst>
-              <a:gd name="adj" fmla="val 4706"/>
-            </a:avLst>
-          </a:prstGeom>
-          <a:solidFill>
-            <a:srgbClr val="0E1A38"/>
-          </a:solidFill>
-          <a:ln w="9525">
-            <a:solidFill>
-              <a:srgbClr val="D49A53"/>
-            </a:solidFill>
-            <a:prstDash val="solid"/>
-          </a:ln>
-        </p:spPr>
-      </p:sp>
-      <p:sp>
-        <p:nvSpPr>
-          <p:cNvPr id="6" name="Text 4"/>
-          <p:cNvSpPr/>
-          <p:nvPr/>
-        </p:nvSpPr>
-        <p:spPr>
-          <a:xfrm>
-            <a:off x="640080" y="4251960"/>
-            <a:ext cx="3454298" cy="731520"/>
+              <a:t>B2B agent commerce by 2028 · Gartner</a:t>
+            </a:r>
+            <a:endParaRPr lang="en-US" sz="1150" dirty="0"/>
+          </a:p>
+        </p:txBody>
+      </p:sp>
+      <p:sp>
+        <p:nvSpPr>
+          <p:cNvPr id="15" name="Text 13"/>
+          <p:cNvSpPr/>
+          <p:nvPr/>
+        </p:nvSpPr>
+        <p:spPr>
+          <a:xfrm>
+            <a:off x="777240" y="5715000"/>
+            <a:ext cx="10637215" cy="365760"/>
           </a:xfrm>
           <a:prstGeom prst="rect">
             <a:avLst/>
@@ -1774,307 +2070,19 @@
           <a:bodyPr wrap="square" rtlCol="0" anchor="ctr"/>
           <a:lstStyle/>
           <a:p>
-            <a:pPr algn="ctr" indent="0" marL="0">
+            <a:pPr indent="0" marL="0">
               <a:buNone/>
             </a:pPr>
             <a:r>
-              <a:rPr lang="en-US" sz="3400" b="1" dirty="0">
-                <a:solidFill>
-                  <a:srgbClr val="D4A074"/>
+              <a:rPr lang="en-US" sz="1600" i="1" dirty="0">
+                <a:solidFill>
+                  <a:srgbClr val="F4EFE6"/>
                 </a:solidFill>
                 <a:latin typeface="Georgia" pitchFamily="34" charset="0"/>
                 <a:ea typeface="Georgia" pitchFamily="34" charset="-122"/>
                 <a:cs typeface="Georgia" pitchFamily="34" charset="-120"/>
               </a:rPr>
-              <a:t>$33T</a:t>
-            </a:r>
-            <a:endParaRPr lang="en-US" sz="3400" dirty="0"/>
-          </a:p>
-        </p:txBody>
-      </p:sp>
-      <p:sp>
-        <p:nvSpPr>
-          <p:cNvPr id="7" name="Text 5"/>
-          <p:cNvSpPr/>
-          <p:nvPr/>
-        </p:nvSpPr>
-        <p:spPr>
-          <a:xfrm>
-            <a:off x="777240" y="4983480"/>
-            <a:ext cx="3179978" cy="640080"/>
-          </a:xfrm>
-          <a:prstGeom prst="rect">
-            <a:avLst/>
-          </a:prstGeom>
-          <a:noFill/>
-          <a:ln/>
-        </p:spPr>
-        <p:txBody>
-          <a:bodyPr wrap="square" rtlCol="0" anchor="ctr"/>
-          <a:lstStyle/>
-          <a:p>
-            <a:pPr algn="ctr" indent="0" marL="0">
-              <a:buNone/>
-            </a:pPr>
-            <a:r>
-              <a:rPr lang="en-US" sz="1200" dirty="0">
-                <a:solidFill>
-                  <a:srgbClr val="94A0B8"/>
-                </a:solidFill>
-                <a:latin typeface="Calibri" pitchFamily="34" charset="0"/>
-                <a:ea typeface="Calibri" pitchFamily="34" charset="-122"/>
-                <a:cs typeface="Calibri" pitchFamily="34" charset="-120"/>
-              </a:rPr>
-              <a:t>stablecoin volume in 2025 — past Visa</a:t>
-            </a:r>
-            <a:endParaRPr lang="en-US" sz="1200" dirty="0"/>
-          </a:p>
-        </p:txBody>
-      </p:sp>
-      <p:sp>
-        <p:nvSpPr>
-          <p:cNvPr id="8" name="Shape 6"/>
-          <p:cNvSpPr/>
-          <p:nvPr/>
-        </p:nvSpPr>
-        <p:spPr>
-          <a:xfrm>
-            <a:off x="4368698" y="4114800"/>
-            <a:ext cx="3454298" cy="1554480"/>
-          </a:xfrm>
-          <a:prstGeom prst="roundRect">
-            <a:avLst>
-              <a:gd name="adj" fmla="val 4706"/>
-            </a:avLst>
-          </a:prstGeom>
-          <a:solidFill>
-            <a:srgbClr val="0E1A38"/>
-          </a:solidFill>
-          <a:ln w="9525">
-            <a:solidFill>
-              <a:srgbClr val="D49A53"/>
-            </a:solidFill>
-            <a:prstDash val="solid"/>
-          </a:ln>
-        </p:spPr>
-      </p:sp>
-      <p:sp>
-        <p:nvSpPr>
-          <p:cNvPr id="9" name="Text 7"/>
-          <p:cNvSpPr/>
-          <p:nvPr/>
-        </p:nvSpPr>
-        <p:spPr>
-          <a:xfrm>
-            <a:off x="4368698" y="4251960"/>
-            <a:ext cx="3454298" cy="731520"/>
-          </a:xfrm>
-          <a:prstGeom prst="rect">
-            <a:avLst/>
-          </a:prstGeom>
-          <a:noFill/>
-          <a:ln/>
-        </p:spPr>
-        <p:txBody>
-          <a:bodyPr wrap="square" rtlCol="0" anchor="ctr"/>
-          <a:lstStyle/>
-          <a:p>
-            <a:pPr algn="ctr" indent="0" marL="0">
-              <a:buNone/>
-            </a:pPr>
-            <a:r>
-              <a:rPr lang="en-US" sz="3400" b="1" dirty="0">
-                <a:solidFill>
-                  <a:srgbClr val="D4A074"/>
-                </a:solidFill>
-                <a:latin typeface="Georgia" pitchFamily="34" charset="0"/>
-                <a:ea typeface="Georgia" pitchFamily="34" charset="-122"/>
-                <a:cs typeface="Georgia" pitchFamily="34" charset="-120"/>
-              </a:rPr>
-              <a:t>$3–5T</a:t>
-            </a:r>
-            <a:endParaRPr lang="en-US" sz="3400" dirty="0"/>
-          </a:p>
-        </p:txBody>
-      </p:sp>
-      <p:sp>
-        <p:nvSpPr>
-          <p:cNvPr id="10" name="Text 8"/>
-          <p:cNvSpPr/>
-          <p:nvPr/>
-        </p:nvSpPr>
-        <p:spPr>
-          <a:xfrm>
-            <a:off x="4505858" y="4983480"/>
-            <a:ext cx="3179978" cy="640080"/>
-          </a:xfrm>
-          <a:prstGeom prst="rect">
-            <a:avLst/>
-          </a:prstGeom>
-          <a:noFill/>
-          <a:ln/>
-        </p:spPr>
-        <p:txBody>
-          <a:bodyPr wrap="square" rtlCol="0" anchor="ctr"/>
-          <a:lstStyle/>
-          <a:p>
-            <a:pPr algn="ctr" indent="0" marL="0">
-              <a:buNone/>
-            </a:pPr>
-            <a:r>
-              <a:rPr lang="en-US" sz="1200" dirty="0">
-                <a:solidFill>
-                  <a:srgbClr val="94A0B8"/>
-                </a:solidFill>
-                <a:latin typeface="Calibri" pitchFamily="34" charset="0"/>
-                <a:ea typeface="Calibri" pitchFamily="34" charset="-122"/>
-                <a:cs typeface="Calibri" pitchFamily="34" charset="-120"/>
-              </a:rPr>
-              <a:t>agent commerce by 2030 (McKinsey)</a:t>
-            </a:r>
-            <a:endParaRPr lang="en-US" sz="1200" dirty="0"/>
-          </a:p>
-        </p:txBody>
-      </p:sp>
-      <p:sp>
-        <p:nvSpPr>
-          <p:cNvPr id="11" name="Shape 9"/>
-          <p:cNvSpPr/>
-          <p:nvPr/>
-        </p:nvSpPr>
-        <p:spPr>
-          <a:xfrm>
-            <a:off x="8097317" y="4114800"/>
-            <a:ext cx="3454298" cy="1554480"/>
-          </a:xfrm>
-          <a:prstGeom prst="roundRect">
-            <a:avLst>
-              <a:gd name="adj" fmla="val 4706"/>
-            </a:avLst>
-          </a:prstGeom>
-          <a:solidFill>
-            <a:srgbClr val="0E1A38"/>
-          </a:solidFill>
-          <a:ln w="9525">
-            <a:solidFill>
-              <a:srgbClr val="D49A53"/>
-            </a:solidFill>
-            <a:prstDash val="solid"/>
-          </a:ln>
-        </p:spPr>
-      </p:sp>
-      <p:sp>
-        <p:nvSpPr>
-          <p:cNvPr id="12" name="Text 10"/>
-          <p:cNvSpPr/>
-          <p:nvPr/>
-        </p:nvSpPr>
-        <p:spPr>
-          <a:xfrm>
-            <a:off x="8097317" y="4251960"/>
-            <a:ext cx="3454298" cy="731520"/>
-          </a:xfrm>
-          <a:prstGeom prst="rect">
-            <a:avLst/>
-          </a:prstGeom>
-          <a:noFill/>
-          <a:ln/>
-        </p:spPr>
-        <p:txBody>
-          <a:bodyPr wrap="square" rtlCol="0" anchor="ctr"/>
-          <a:lstStyle/>
-          <a:p>
-            <a:pPr algn="ctr" indent="0" marL="0">
-              <a:buNone/>
-            </a:pPr>
-            <a:r>
-              <a:rPr lang="en-US" sz="3400" b="1" dirty="0">
-                <a:solidFill>
-                  <a:srgbClr val="D4A074"/>
-                </a:solidFill>
-                <a:latin typeface="Georgia" pitchFamily="34" charset="0"/>
-                <a:ea typeface="Georgia" pitchFamily="34" charset="-122"/>
-                <a:cs typeface="Georgia" pitchFamily="34" charset="-120"/>
-              </a:rPr>
-              <a:t>$15T</a:t>
-            </a:r>
-            <a:endParaRPr lang="en-US" sz="3400" dirty="0"/>
-          </a:p>
-        </p:txBody>
-      </p:sp>
-      <p:sp>
-        <p:nvSpPr>
-          <p:cNvPr id="13" name="Text 11"/>
-          <p:cNvSpPr/>
-          <p:nvPr/>
-        </p:nvSpPr>
-        <p:spPr>
-          <a:xfrm>
-            <a:off x="8234477" y="4983480"/>
-            <a:ext cx="3179978" cy="640080"/>
-          </a:xfrm>
-          <a:prstGeom prst="rect">
-            <a:avLst/>
-          </a:prstGeom>
-          <a:noFill/>
-          <a:ln/>
-        </p:spPr>
-        <p:txBody>
-          <a:bodyPr wrap="square" rtlCol="0" anchor="ctr"/>
-          <a:lstStyle/>
-          <a:p>
-            <a:pPr algn="ctr" indent="0" marL="0">
-              <a:buNone/>
-            </a:pPr>
-            <a:r>
-              <a:rPr lang="en-US" sz="1200" dirty="0">
-                <a:solidFill>
-                  <a:srgbClr val="94A0B8"/>
-                </a:solidFill>
-                <a:latin typeface="Calibri" pitchFamily="34" charset="0"/>
-                <a:ea typeface="Calibri" pitchFamily="34" charset="-122"/>
-                <a:cs typeface="Calibri" pitchFamily="34" charset="-120"/>
-              </a:rPr>
-              <a:t>B2B agent commerce by 2028 (Gartner)</a:t>
-            </a:r>
-            <a:endParaRPr lang="en-US" sz="1200" dirty="0"/>
-          </a:p>
-        </p:txBody>
-      </p:sp>
-      <p:sp>
-        <p:nvSpPr>
-          <p:cNvPr id="14" name="Text 12"/>
-          <p:cNvSpPr/>
-          <p:nvPr/>
-        </p:nvSpPr>
-        <p:spPr>
-          <a:xfrm>
-            <a:off x="640080" y="5989320"/>
-            <a:ext cx="10911535" cy="365760"/>
-          </a:xfrm>
-          <a:prstGeom prst="rect">
-            <a:avLst/>
-          </a:prstGeom>
-          <a:noFill/>
-          <a:ln/>
-        </p:spPr>
-        <p:txBody>
-          <a:bodyPr wrap="square" rtlCol="0" anchor="ctr"/>
-          <a:lstStyle/>
-          <a:p>
-            <a:pPr indent="0" marL="0">
-              <a:buNone/>
-            </a:pPr>
-            <a:r>
-              <a:rPr lang="en-US" sz="1600" i="1" dirty="0">
-                <a:solidFill>
-                  <a:srgbClr val="F4EFE6"/>
-                </a:solidFill>
-                <a:latin typeface="Georgia" pitchFamily="34" charset="0"/>
-                <a:ea typeface="Georgia" pitchFamily="34" charset="-122"/>
-                <a:cs typeface="Georgia" pitchFamily="34" charset="-120"/>
-              </a:rPr>
-              <a:t>We call it the Sips Economy.</a:t>
+              <a:t>We call it the Sips Economy — 1 sip = $0.0001.</a:t>
             </a:r>
             <a:endParaRPr lang="en-US" sz="1600" dirty="0"/>
           </a:p>
@@ -2120,8 +2128,8 @@
         </p:nvSpPr>
         <p:spPr>
           <a:xfrm>
-            <a:off x="640080" y="502920"/>
-            <a:ext cx="10911535" cy="274320"/>
+            <a:off x="11277295" y="6355080"/>
+            <a:ext cx="548640" cy="274320"/>
           </a:xfrm>
           <a:prstGeom prst="rect">
             <a:avLst/>
@@ -2133,138 +2141,159 @@
           <a:bodyPr wrap="square" rtlCol="0" anchor="ctr"/>
           <a:lstStyle/>
           <a:p>
+            <a:pPr algn="r" indent="0" marL="0">
+              <a:buNone/>
+            </a:pPr>
+            <a:r>
+              <a:rPr lang="en-US" sz="900" dirty="0">
+                <a:solidFill>
+                  <a:srgbClr val="94A0B8"/>
+                </a:solidFill>
+                <a:latin typeface="Roboto Mono" pitchFamily="34" charset="0"/>
+                <a:ea typeface="Roboto Mono" pitchFamily="34" charset="-122"/>
+                <a:cs typeface="Roboto Mono" pitchFamily="34" charset="-120"/>
+              </a:rPr>
+              <a:t>03</a:t>
+            </a:r>
+            <a:endParaRPr lang="en-US" sz="900" dirty="0"/>
+          </a:p>
+        </p:txBody>
+      </p:sp>
+      <p:sp>
+        <p:nvSpPr>
+          <p:cNvPr id="3" name="Text 1"/>
+          <p:cNvSpPr/>
+          <p:nvPr/>
+        </p:nvSpPr>
+        <p:spPr>
+          <a:xfrm>
+            <a:off x="777240" y="566928"/>
+            <a:ext cx="10637215" cy="274320"/>
+          </a:xfrm>
+          <a:prstGeom prst="rect">
+            <a:avLst/>
+          </a:prstGeom>
+          <a:noFill/>
+          <a:ln/>
+        </p:spPr>
+        <p:txBody>
+          <a:bodyPr wrap="square" rtlCol="0" anchor="ctr"/>
+          <a:lstStyle/>
+          <a:p>
             <a:pPr indent="0" marL="0">
               <a:buNone/>
             </a:pPr>
             <a:r>
-              <a:rPr lang="en-US" sz="1200" b="1" spc="200" kern="0" dirty="0">
+              <a:rPr lang="en-US" sz="1100" spc="300" kern="0" dirty="0">
                 <a:solidFill>
                   <a:srgbClr val="D49A53"/>
+                </a:solidFill>
+                <a:latin typeface="Roboto Mono" pitchFamily="34" charset="0"/>
+                <a:ea typeface="Roboto Mono" pitchFamily="34" charset="-122"/>
+                <a:cs typeface="Roboto Mono" pitchFamily="34" charset="-120"/>
+              </a:rPr>
+              <a:t>WHAT'S OURS</a:t>
+            </a:r>
+            <a:endParaRPr lang="en-US" sz="1100" dirty="0"/>
+          </a:p>
+        </p:txBody>
+      </p:sp>
+      <p:sp>
+        <p:nvSpPr>
+          <p:cNvPr id="4" name="Text 2"/>
+          <p:cNvSpPr/>
+          <p:nvPr/>
+        </p:nvSpPr>
+        <p:spPr>
+          <a:xfrm>
+            <a:off x="777240" y="960120"/>
+            <a:ext cx="10637215" cy="868680"/>
+          </a:xfrm>
+          <a:prstGeom prst="rect">
+            <a:avLst/>
+          </a:prstGeom>
+          <a:noFill/>
+          <a:ln/>
+        </p:spPr>
+        <p:txBody>
+          <a:bodyPr wrap="square" rtlCol="0" anchor="ctr"/>
+          <a:lstStyle/>
+          <a:p>
+            <a:pPr indent="0" marL="0">
+              <a:buNone/>
+            </a:pPr>
+            <a:r>
+              <a:rPr lang="en-US" sz="3200" b="1" dirty="0">
+                <a:solidFill>
+                  <a:srgbClr val="F4EFE6"/>
+                </a:solidFill>
+                <a:latin typeface="Georgia" pitchFamily="34" charset="0"/>
+                <a:ea typeface="Georgia" pitchFamily="34" charset="-122"/>
+                <a:cs typeface="Georgia" pitchFamily="34" charset="-120"/>
+              </a:rPr>
+              <a:t>The trust root, not the rail.</a:t>
+            </a:r>
+            <a:endParaRPr lang="en-US" sz="3200" dirty="0"/>
+          </a:p>
+        </p:txBody>
+      </p:sp>
+      <p:sp>
+        <p:nvSpPr>
+          <p:cNvPr id="5" name="Text 3"/>
+          <p:cNvSpPr/>
+          <p:nvPr/>
+        </p:nvSpPr>
+        <p:spPr>
+          <a:xfrm>
+            <a:off x="777240" y="2057400"/>
+            <a:ext cx="10637215" cy="2926080"/>
+          </a:xfrm>
+          <a:prstGeom prst="rect">
+            <a:avLst/>
+          </a:prstGeom>
+          <a:noFill/>
+          <a:ln/>
+        </p:spPr>
+        <p:txBody>
+          <a:bodyPr wrap="square" rtlCol="0" anchor="ctr"/>
+          <a:lstStyle/>
+          <a:p>
+            <a:pPr marL="228600" indent="-228600">
+              <a:lnSpc>
+                <a:spcPct val="110000"/>
+              </a:lnSpc>
+              <a:spcAft>
+                <a:spcPts val="1400"/>
+              </a:spcAft>
+              <a:buSzPct val="100000"/>
+              <a:buChar char="◆"/>
+            </a:pPr>
+            <a:r>
+              <a:rPr lang="en-US" sz="1700" dirty="0">
+                <a:solidFill>
+                  <a:srgbClr val="F4EFE6"/>
                 </a:solidFill>
                 <a:latin typeface="Calibri" pitchFamily="34" charset="0"/>
                 <a:ea typeface="Calibri" pitchFamily="34" charset="-122"/>
                 <a:cs typeface="Calibri" pitchFamily="34" charset="-120"/>
               </a:rPr>
-              <a:t>WHAT'S OURS</a:t>
-            </a:r>
-            <a:endParaRPr lang="en-US" sz="1200" dirty="0"/>
-          </a:p>
-        </p:txBody>
-      </p:sp>
-      <p:sp>
-        <p:nvSpPr>
-          <p:cNvPr id="3" name="Text 1"/>
-          <p:cNvSpPr/>
-          <p:nvPr/>
-        </p:nvSpPr>
-        <p:spPr>
-          <a:xfrm>
-            <a:off x="640080" y="868680"/>
-            <a:ext cx="10911535" cy="914400"/>
-          </a:xfrm>
-          <a:prstGeom prst="rect">
-            <a:avLst/>
-          </a:prstGeom>
-          <a:noFill/>
-          <a:ln/>
-        </p:spPr>
-        <p:txBody>
-          <a:bodyPr wrap="square" rtlCol="0" anchor="ctr"/>
-          <a:lstStyle/>
-          <a:p>
-            <a:pPr indent="0" marL="0">
+              <a:t>An agent needs an identity before it can pay. That part is ours.</a:t>
+            </a:r>
+            <a:endParaRPr lang="en-US" sz="1700" dirty="0"/>
+          </a:p>
+          <a:p>
+            <a:pPr marL="228600" indent="-228600">
               <a:lnSpc>
-                <a:spcPct val="100000"/>
-              </a:lnSpc>
-              <a:buNone/>
-            </a:pPr>
-            <a:r>
-              <a:rPr lang="en-US" sz="3200" b="1" dirty="0">
-                <a:solidFill>
-                  <a:srgbClr val="F4EFE6"/>
-                </a:solidFill>
-                <a:latin typeface="Georgia" pitchFamily="34" charset="0"/>
-                <a:ea typeface="Georgia" pitchFamily="34" charset="-122"/>
-                <a:cs typeface="Georgia" pitchFamily="34" charset="-120"/>
-              </a:rPr>
-              <a:t>Sippar is the trust root, not the rail.</a:t>
-            </a:r>
-            <a:endParaRPr lang="en-US" sz="3200" dirty="0"/>
-          </a:p>
-        </p:txBody>
-      </p:sp>
-      <p:sp>
-        <p:nvSpPr>
-          <p:cNvPr id="4" name="Text 2"/>
-          <p:cNvSpPr/>
-          <p:nvPr/>
-        </p:nvSpPr>
-        <p:spPr>
-          <a:xfrm>
-            <a:off x="640080" y="1965960"/>
-            <a:ext cx="10911535" cy="457200"/>
-          </a:xfrm>
-          <a:prstGeom prst="rect">
-            <a:avLst/>
-          </a:prstGeom>
-          <a:noFill/>
-          <a:ln/>
-        </p:spPr>
-        <p:txBody>
-          <a:bodyPr wrap="square" rtlCol="0" anchor="ctr"/>
-          <a:lstStyle/>
-          <a:p>
-            <a:pPr indent="0" marL="0">
-              <a:buNone/>
-            </a:pPr>
-            <a:r>
-              <a:rPr lang="en-US" sz="1800" i="1" dirty="0">
-                <a:solidFill>
-                  <a:srgbClr val="D4A074"/>
-                </a:solidFill>
-                <a:latin typeface="Georgia" pitchFamily="34" charset="0"/>
-                <a:ea typeface="Georgia" pitchFamily="34" charset="-122"/>
-                <a:cs typeface="Georgia" pitchFamily="34" charset="-120"/>
-              </a:rPr>
-              <a:t>An agent needs an identity before it can pay. That part is ours.</a:t>
-            </a:r>
-            <a:endParaRPr lang="en-US" sz="1800" dirty="0"/>
-          </a:p>
-        </p:txBody>
-      </p:sp>
-      <p:sp>
-        <p:nvSpPr>
-          <p:cNvPr id="5" name="Text 3"/>
-          <p:cNvSpPr/>
-          <p:nvPr/>
-        </p:nvSpPr>
-        <p:spPr>
-          <a:xfrm>
-            <a:off x="640080" y="2697480"/>
-            <a:ext cx="10911535" cy="2377440"/>
-          </a:xfrm>
-          <a:prstGeom prst="rect">
-            <a:avLst/>
-          </a:prstGeom>
-          <a:noFill/>
-          <a:ln/>
-        </p:spPr>
-        <p:txBody>
-          <a:bodyPr wrap="square" rtlCol="0" anchor="ctr"/>
-          <a:lstStyle/>
-          <a:p>
-            <a:pPr marL="342900" indent="-342900">
-              <a:lnSpc>
-                <a:spcPct val="120000"/>
+                <a:spcPct val="110000"/>
               </a:lnSpc>
               <a:spcAft>
-                <a:spcPts val="1200"/>
+                <a:spcPts val="1400"/>
               </a:spcAft>
               <a:buSzPct val="100000"/>
-              <a:buChar char="•"/>
-            </a:pPr>
-            <a:r>
-              <a:rPr lang="en-US" sz="1600" dirty="0">
+              <a:buChar char="◆"/>
+            </a:pPr>
+            <a:r>
+              <a:rPr lang="en-US" sz="1700" dirty="0">
                 <a:solidFill>
                   <a:srgbClr val="F4EFE6"/>
                 </a:solidFill>
@@ -2272,23 +2301,23 @@
                 <a:ea typeface="Calibri" pitchFamily="34" charset="-122"/>
                 <a:cs typeface="Calibri" pitchFamily="34" charset="-120"/>
               </a:rPr>
-              <a:t>One signing key, split across 34 independent operators in different countries — no single party can assemble it. The private key never exists in one place.</a:t>
-            </a:r>
-            <a:endParaRPr lang="en-US" sz="1600" dirty="0"/>
-          </a:p>
-          <a:p>
-            <a:pPr marL="342900" indent="-342900">
+              <a:t>One signing key, split across 34 independent operators — assembled by no one.</a:t>
+            </a:r>
+            <a:endParaRPr lang="en-US" sz="1700" dirty="0"/>
+          </a:p>
+          <a:p>
+            <a:pPr marL="228600" indent="-228600">
               <a:lnSpc>
-                <a:spcPct val="120000"/>
+                <a:spcPct val="110000"/>
               </a:lnSpc>
               <a:spcAft>
-                <a:spcPts val="1200"/>
+                <a:spcPts val="1400"/>
               </a:spcAft>
               <a:buSzPct val="100000"/>
-              <a:buChar char="•"/>
-            </a:pPr>
-            <a:r>
-              <a:rPr lang="en-US" sz="1600" dirty="0">
+              <a:buChar char="◆"/>
+            </a:pPr>
+            <a:r>
+              <a:rPr lang="en-US" sz="1700" dirty="0">
                 <a:solidFill>
                   <a:srgbClr val="F4EFE6"/>
                 </a:solidFill>
@@ -2296,23 +2325,23 @@
                 <a:ea typeface="Calibri" pitchFamily="34" charset="-122"/>
                 <a:cs typeface="Calibri" pitchFamily="34" charset="-120"/>
               </a:rPr>
-              <a:t>The same identity pays across 10 chains (incl. Algorand) and the card rails — Visa TAP, Mastercard Agent Pay, Google AP2. The wrapping differs; the trust root doesn't.</a:t>
-            </a:r>
-            <a:endParaRPr lang="en-US" sz="1600" dirty="0"/>
-          </a:p>
-          <a:p>
-            <a:pPr marL="342900" indent="-342900">
+              <a:t>The same identity pays across 10 chains and the card rails — Visa, Mastercard, Google AP2.</a:t>
+            </a:r>
+            <a:endParaRPr lang="en-US" sz="1700" dirty="0"/>
+          </a:p>
+          <a:p>
+            <a:pPr marL="228600" indent="-228600">
               <a:lnSpc>
-                <a:spcPct val="120000"/>
+                <a:spcPct val="110000"/>
               </a:lnSpc>
               <a:spcAft>
-                <a:spcPts val="1200"/>
+                <a:spcPts val="1400"/>
               </a:spcAft>
               <a:buSzPct val="100000"/>
-              <a:buChar char="•"/>
-            </a:pPr>
-            <a:r>
-              <a:rPr lang="en-US" sz="1600" dirty="0">
+              <a:buChar char="◆"/>
+            </a:pPr>
+            <a:r>
+              <a:rPr lang="en-US" sz="1700" dirty="0">
                 <a:solidFill>
                   <a:srgbClr val="F4EFE6"/>
                 </a:solidFill>
@@ -2320,9 +2349,9 @@
                 <a:ea typeface="Calibri" pitchFamily="34" charset="-122"/>
                 <a:cs typeface="Calibri" pitchFamily="34" charset="-120"/>
               </a:rPr>
-              <a:t>The same identity also pays people, not just machines. The economy isn't a closed AI loop — it's a settlement layer that pays whoever finishes the task.</a:t>
-            </a:r>
-            <a:endParaRPr lang="en-US" sz="1600" dirty="0"/>
+              <a:t>It pays people too, not just machines — whoever finishes the task.</a:t>
+            </a:r>
+            <a:endParaRPr lang="en-US" sz="1700" dirty="0"/>
           </a:p>
         </p:txBody>
       </p:sp>
@@ -2334,8 +2363,8 @@
         </p:nvSpPr>
         <p:spPr>
           <a:xfrm>
-            <a:off x="640080" y="5760720"/>
-            <a:ext cx="10911535" cy="457200"/>
+            <a:off x="777240" y="5715000"/>
+            <a:ext cx="10637215" cy="411480"/>
           </a:xfrm>
           <a:prstGeom prst="rect">
             <a:avLst/>
@@ -2405,8 +2434,8 @@
         </p:nvSpPr>
         <p:spPr>
           <a:xfrm>
-            <a:off x="640080" y="502920"/>
-            <a:ext cx="10911535" cy="274320"/>
+            <a:off x="11277295" y="6355080"/>
+            <a:ext cx="548640" cy="274320"/>
           </a:xfrm>
           <a:prstGeom prst="rect">
             <a:avLst/>
@@ -2418,34 +2447,73 @@
           <a:bodyPr wrap="square" rtlCol="0" anchor="ctr"/>
           <a:lstStyle/>
           <a:p>
+            <a:pPr algn="r" indent="0" marL="0">
+              <a:buNone/>
+            </a:pPr>
+            <a:r>
+              <a:rPr lang="en-US" sz="900" dirty="0">
+                <a:solidFill>
+                  <a:srgbClr val="94A0B8"/>
+                </a:solidFill>
+                <a:latin typeface="Roboto Mono" pitchFamily="34" charset="0"/>
+                <a:ea typeface="Roboto Mono" pitchFamily="34" charset="-122"/>
+                <a:cs typeface="Roboto Mono" pitchFamily="34" charset="-120"/>
+              </a:rPr>
+              <a:t>04</a:t>
+            </a:r>
+            <a:endParaRPr lang="en-US" sz="900" dirty="0"/>
+          </a:p>
+        </p:txBody>
+      </p:sp>
+      <p:sp>
+        <p:nvSpPr>
+          <p:cNvPr id="3" name="Text 1"/>
+          <p:cNvSpPr/>
+          <p:nvPr/>
+        </p:nvSpPr>
+        <p:spPr>
+          <a:xfrm>
+            <a:off x="777240" y="566928"/>
+            <a:ext cx="10637215" cy="274320"/>
+          </a:xfrm>
+          <a:prstGeom prst="rect">
+            <a:avLst/>
+          </a:prstGeom>
+          <a:noFill/>
+          <a:ln/>
+        </p:spPr>
+        <p:txBody>
+          <a:bodyPr wrap="square" rtlCol="0" anchor="ctr"/>
+          <a:lstStyle/>
+          <a:p>
             <a:pPr indent="0" marL="0">
               <a:buNone/>
             </a:pPr>
             <a:r>
-              <a:rPr lang="en-US" sz="1200" b="1" spc="200" kern="0" dirty="0">
+              <a:rPr lang="en-US" sz="1100" spc="300" kern="0" dirty="0">
                 <a:solidFill>
                   <a:srgbClr val="D49A53"/>
                 </a:solidFill>
-                <a:latin typeface="Calibri" pitchFamily="34" charset="0"/>
-                <a:ea typeface="Calibri" pitchFamily="34" charset="-122"/>
-                <a:cs typeface="Calibri" pitchFamily="34" charset="-120"/>
+                <a:latin typeface="Roboto Mono" pitchFamily="34" charset="0"/>
+                <a:ea typeface="Roboto Mono" pitchFamily="34" charset="-122"/>
+                <a:cs typeface="Roboto Mono" pitchFamily="34" charset="-120"/>
               </a:rPr>
               <a:t>BRINGING THE SIPS ECONOMY TO ALGORAND</a:t>
             </a:r>
-            <a:endParaRPr lang="en-US" sz="1200" dirty="0"/>
-          </a:p>
-        </p:txBody>
-      </p:sp>
-      <p:sp>
-        <p:nvSpPr>
-          <p:cNvPr id="3" name="Text 1"/>
-          <p:cNvSpPr/>
-          <p:nvPr/>
-        </p:nvSpPr>
-        <p:spPr>
-          <a:xfrm>
-            <a:off x="640080" y="868680"/>
-            <a:ext cx="10911535" cy="914400"/>
+            <a:endParaRPr lang="en-US" sz="1100" dirty="0"/>
+          </a:p>
+        </p:txBody>
+      </p:sp>
+      <p:sp>
+        <p:nvSpPr>
+          <p:cNvPr id="4" name="Text 2"/>
+          <p:cNvSpPr/>
+          <p:nvPr/>
+        </p:nvSpPr>
+        <p:spPr>
+          <a:xfrm>
+            <a:off x="777240" y="960120"/>
+            <a:ext cx="10637215" cy="868680"/>
           </a:xfrm>
           <a:prstGeom prst="rect">
             <a:avLst/>
@@ -2458,9 +2526,6 @@
           <a:lstStyle/>
           <a:p>
             <a:pPr indent="0" marL="0">
-              <a:lnSpc>
-                <a:spcPct val="100000"/>
-              </a:lnSpc>
               <a:buNone/>
             </a:pPr>
             <a:r>
@@ -2472,7 +2537,7 @@
                 <a:ea typeface="Georgia" pitchFamily="34" charset="-122"/>
                 <a:cs typeface="Georgia" pitchFamily="34" charset="-120"/>
               </a:rPr>
-              <a:t>The wall — and Sippar's answer.</a:t>
+              <a:t>Any chain in  →  Algorand out.</a:t>
             </a:r>
             <a:endParaRPr lang="en-US" sz="3200" dirty="0"/>
           </a:p>
@@ -2480,18 +2545,18 @@
       </p:sp>
       <p:sp>
         <p:nvSpPr>
-          <p:cNvPr id="4" name="Shape 2"/>
-          <p:cNvSpPr/>
-          <p:nvPr/>
-        </p:nvSpPr>
-        <p:spPr>
-          <a:xfrm>
-            <a:off x="640080" y="2286000"/>
-            <a:ext cx="5227168" cy="3291840"/>
+          <p:cNvPr id="5" name="Shape 3"/>
+          <p:cNvSpPr/>
+          <p:nvPr/>
+        </p:nvSpPr>
+        <p:spPr>
+          <a:xfrm>
+            <a:off x="777240" y="2148840"/>
+            <a:ext cx="5090008" cy="3200400"/>
           </a:xfrm>
           <a:prstGeom prst="roundRect">
             <a:avLst>
-              <a:gd name="adj" fmla="val 1667"/>
+              <a:gd name="adj" fmla="val 1714"/>
             </a:avLst>
           </a:prstGeom>
           <a:solidFill>
@@ -2507,14 +2572,14 @@
       </p:sp>
       <p:sp>
         <p:nvSpPr>
-          <p:cNvPr id="5" name="Text 3"/>
-          <p:cNvSpPr/>
-          <p:nvPr/>
-        </p:nvSpPr>
-        <p:spPr>
-          <a:xfrm>
-            <a:off x="914400" y="2468880"/>
-            <a:ext cx="4678528" cy="365760"/>
+          <p:cNvPr id="6" name="Text 4"/>
+          <p:cNvSpPr/>
+          <p:nvPr/>
+        </p:nvSpPr>
+        <p:spPr>
+          <a:xfrm>
+            <a:off x="1051560" y="2377440"/>
+            <a:ext cx="4541368" cy="320040"/>
           </a:xfrm>
           <a:prstGeom prst="rect">
             <a:avLst/>
@@ -2530,30 +2595,30 @@
               <a:buNone/>
             </a:pPr>
             <a:r>
-              <a:rPr lang="en-US" sz="1800" b="1" dirty="0">
+              <a:rPr lang="en-US" sz="1200" spc="200" kern="0" dirty="0">
                 <a:solidFill>
                   <a:srgbClr val="94A0B8"/>
                 </a:solidFill>
-                <a:latin typeface="Georgia" pitchFamily="34" charset="0"/>
-                <a:ea typeface="Georgia" pitchFamily="34" charset="-122"/>
-                <a:cs typeface="Georgia" pitchFamily="34" charset="-120"/>
-              </a:rPr>
-              <a:t>The wall</a:t>
-            </a:r>
-            <a:endParaRPr lang="en-US" sz="1800" dirty="0"/>
-          </a:p>
-        </p:txBody>
-      </p:sp>
-      <p:sp>
-        <p:nvSpPr>
-          <p:cNvPr id="6" name="Text 4"/>
-          <p:cNvSpPr/>
-          <p:nvPr/>
-        </p:nvSpPr>
-        <p:spPr>
-          <a:xfrm>
-            <a:off x="914400" y="2926080"/>
-            <a:ext cx="4678528" cy="2468880"/>
+                <a:latin typeface="Roboto Mono" pitchFamily="34" charset="0"/>
+                <a:ea typeface="Roboto Mono" pitchFamily="34" charset="-122"/>
+                <a:cs typeface="Roboto Mono" pitchFamily="34" charset="-120"/>
+              </a:rPr>
+              <a:t>THE WALL</a:t>
+            </a:r>
+            <a:endParaRPr lang="en-US" sz="1200" dirty="0"/>
+          </a:p>
+        </p:txBody>
+      </p:sp>
+      <p:sp>
+        <p:nvSpPr>
+          <p:cNvPr id="7" name="Text 5"/>
+          <p:cNvSpPr/>
+          <p:nvPr/>
+        </p:nvSpPr>
+        <p:spPr>
+          <a:xfrm>
+            <a:off x="1051560" y="2834640"/>
+            <a:ext cx="4541368" cy="2286000"/>
           </a:xfrm>
           <a:prstGeom prst="rect">
             <a:avLst/>
@@ -2572,7 +2637,7 @@
               <a:buNone/>
             </a:pPr>
             <a:r>
-              <a:rPr lang="en-US" sz="1500" dirty="0">
+              <a:rPr lang="en-US" sz="1600" dirty="0">
                 <a:solidFill>
                   <a:srgbClr val="F4EFE6"/>
                 </a:solidFill>
@@ -2580,9 +2645,9 @@
                 <a:ea typeface="Calibri" pitchFamily="34" charset="-122"/>
                 <a:cs typeface="Calibri" pitchFamily="34" charset="-120"/>
               </a:rPr>
-              <a:t>Nobody can pay an Algorand x402 service without first holding Algorand assets.</a:t>
-            </a:r>
-            <a:endParaRPr lang="en-US" sz="1500" dirty="0"/>
+              <a:t>Nobody pays an Algorand x402 service without first holding Algorand assets.</a:t>
+            </a:r>
+            <a:endParaRPr lang="en-US" sz="1600" dirty="0"/>
           </a:p>
           <a:p>
             <a:pPr indent="0" marL="0">
@@ -2591,7 +2656,7 @@
               </a:lnSpc>
               <a:buNone/>
             </a:pPr>
-            <a:endParaRPr lang="en-US" sz="1500" dirty="0"/>
+            <a:endParaRPr lang="en-US" sz="1600" dirty="0"/>
           </a:p>
           <a:p>
             <a:pPr indent="0" marL="0">
@@ -2601,7 +2666,7 @@
               <a:buNone/>
             </a:pPr>
             <a:r>
-              <a:rPr lang="en-US" sz="1500" dirty="0">
+              <a:rPr lang="en-US" sz="1600" dirty="0">
                 <a:solidFill>
                   <a:srgbClr val="F4EFE6"/>
                 </a:solidFill>
@@ -2609,32 +2674,32 @@
                 <a:ea typeface="Calibri" pitchFamily="34" charset="-122"/>
                 <a:cs typeface="Calibri" pitchFamily="34" charset="-120"/>
               </a:rPr>
-              <a:t>Cross-chain settlement is the industry's unsolved problem — Coinbase CDP, Circle Agent Stack, and AWS AgentCore all settle single-chain.</a:t>
-            </a:r>
-            <a:endParaRPr lang="en-US" sz="1500" dirty="0"/>
-          </a:p>
-        </p:txBody>
-      </p:sp>
-      <p:sp>
-        <p:nvSpPr>
-          <p:cNvPr id="7" name="Shape 5"/>
-          <p:cNvSpPr/>
-          <p:nvPr/>
-        </p:nvSpPr>
-        <p:spPr>
-          <a:xfrm>
-            <a:off x="6324448" y="2286000"/>
-            <a:ext cx="5227168" cy="3291840"/>
+              <a:t>Cross-chain settlement is unsolved — CDP, Circle, AWS all settle single-chain.</a:t>
+            </a:r>
+            <a:endParaRPr lang="en-US" sz="1600" dirty="0"/>
+          </a:p>
+        </p:txBody>
+      </p:sp>
+      <p:sp>
+        <p:nvSpPr>
+          <p:cNvPr id="8" name="Shape 6"/>
+          <p:cNvSpPr/>
+          <p:nvPr/>
+        </p:nvSpPr>
+        <p:spPr>
+          <a:xfrm>
+            <a:off x="6324448" y="2148840"/>
+            <a:ext cx="5090008" cy="3200400"/>
           </a:xfrm>
           <a:prstGeom prst="roundRect">
             <a:avLst>
-              <a:gd name="adj" fmla="val 1667"/>
+              <a:gd name="adj" fmla="val 1714"/>
             </a:avLst>
           </a:prstGeom>
           <a:solidFill>
             <a:srgbClr val="0E1A38"/>
           </a:solidFill>
-          <a:ln w="9525">
+          <a:ln w="12700">
             <a:solidFill>
               <a:srgbClr val="D49A53"/>
             </a:solidFill>
@@ -2644,14 +2709,14 @@
       </p:sp>
       <p:sp>
         <p:nvSpPr>
-          <p:cNvPr id="8" name="Text 6"/>
-          <p:cNvSpPr/>
-          <p:nvPr/>
-        </p:nvSpPr>
-        <p:spPr>
-          <a:xfrm>
-            <a:off x="6598768" y="2468880"/>
-            <a:ext cx="4678528" cy="365760"/>
+          <p:cNvPr id="9" name="Text 7"/>
+          <p:cNvSpPr/>
+          <p:nvPr/>
+        </p:nvSpPr>
+        <p:spPr>
+          <a:xfrm>
+            <a:off x="6598768" y="2377440"/>
+            <a:ext cx="4541368" cy="320040"/>
           </a:xfrm>
           <a:prstGeom prst="rect">
             <a:avLst/>
@@ -2667,30 +2732,30 @@
               <a:buNone/>
             </a:pPr>
             <a:r>
-              <a:rPr lang="en-US" sz="1800" b="1" dirty="0">
+              <a:rPr lang="en-US" sz="1200" spc="200" kern="0" dirty="0">
                 <a:solidFill>
                   <a:srgbClr val="D4A074"/>
                 </a:solidFill>
-                <a:latin typeface="Georgia" pitchFamily="34" charset="0"/>
-                <a:ea typeface="Georgia" pitchFamily="34" charset="-122"/>
-                <a:cs typeface="Georgia" pitchFamily="34" charset="-120"/>
-              </a:rPr>
-              <a:t>Sippar's answer</a:t>
-            </a:r>
-            <a:endParaRPr lang="en-US" sz="1800" dirty="0"/>
-          </a:p>
-        </p:txBody>
-      </p:sp>
-      <p:sp>
-        <p:nvSpPr>
-          <p:cNvPr id="9" name="Text 7"/>
-          <p:cNvSpPr/>
-          <p:nvPr/>
-        </p:nvSpPr>
-        <p:spPr>
-          <a:xfrm>
-            <a:off x="6598768" y="2926080"/>
-            <a:ext cx="4678528" cy="2468880"/>
+                <a:latin typeface="Roboto Mono" pitchFamily="34" charset="0"/>
+                <a:ea typeface="Roboto Mono" pitchFamily="34" charset="-122"/>
+                <a:cs typeface="Roboto Mono" pitchFamily="34" charset="-120"/>
+              </a:rPr>
+              <a:t>SIPPAR</a:t>
+            </a:r>
+            <a:endParaRPr lang="en-US" sz="1200" dirty="0"/>
+          </a:p>
+        </p:txBody>
+      </p:sp>
+      <p:sp>
+        <p:nvSpPr>
+          <p:cNvPr id="10" name="Text 8"/>
+          <p:cNvSpPr/>
+          <p:nvPr/>
+        </p:nvSpPr>
+        <p:spPr>
+          <a:xfrm>
+            <a:off x="6598768" y="2834640"/>
+            <a:ext cx="4541368" cy="2286000"/>
           </a:xfrm>
           <a:prstGeom prst="rect">
             <a:avLst/>
@@ -2709,7 +2774,7 @@
               <a:buNone/>
             </a:pPr>
             <a:r>
-              <a:rPr lang="en-US" sz="1500" dirty="0">
+              <a:rPr lang="en-US" sz="1600" dirty="0">
                 <a:solidFill>
                   <a:srgbClr val="F4EFE6"/>
                 </a:solidFill>
@@ -2717,9 +2782,9 @@
                 <a:ea typeface="Calibri" pitchFamily="34" charset="-122"/>
                 <a:cs typeface="Calibri" pitchFamily="34" charset="-120"/>
               </a:rPr>
-              <a:t>The agent pays on its home chain. Sippar threshold-signs the Algorand x402 payment directly, so the service is paid natively on Algorand.</a:t>
-            </a:r>
-            <a:endParaRPr lang="en-US" sz="1500" dirty="0"/>
+              <a:t>Pay on your home chain. ICP threshold signatures sign the Algorand x402 payment directly.</a:t>
+            </a:r>
+            <a:endParaRPr lang="en-US" sz="1600" dirty="0"/>
           </a:p>
           <a:p>
             <a:pPr indent="0" marL="0">
@@ -2728,7 +2793,7 @@
               </a:lnSpc>
               <a:buNone/>
             </a:pPr>
-            <a:endParaRPr lang="en-US" sz="1500" dirty="0"/>
+            <a:endParaRPr lang="en-US" sz="1600" dirty="0"/>
           </a:p>
           <a:p>
             <a:pPr indent="0" marL="0">
@@ -2738,7 +2803,7 @@
               <a:buNone/>
             </a:pPr>
             <a:r>
-              <a:rPr lang="en-US" sz="1500" dirty="0">
+              <a:rPr lang="en-US" sz="1600" dirty="0">
                 <a:solidFill>
                   <a:srgbClr val="F4EFE6"/>
                 </a:solidFill>
@@ -2746,46 +2811,7 @@
                 <a:ea typeface="Calibri" pitchFamily="34" charset="-122"/>
                 <a:cs typeface="Calibri" pitchFamily="34" charset="-120"/>
               </a:rPr>
-              <a:t>ICP-distributed key — no private key, no custodian, no bridge. The agent never holds an Algorand asset.</a:t>
-            </a:r>
-            <a:endParaRPr lang="en-US" sz="1500" dirty="0"/>
-          </a:p>
-        </p:txBody>
-      </p:sp>
-      <p:sp>
-        <p:nvSpPr>
-          <p:cNvPr id="10" name="Text 8"/>
-          <p:cNvSpPr/>
-          <p:nvPr/>
-        </p:nvSpPr>
-        <p:spPr>
-          <a:xfrm>
-            <a:off x="640080" y="5806440"/>
-            <a:ext cx="10911535" cy="365760"/>
-          </a:xfrm>
-          <a:prstGeom prst="rect">
-            <a:avLst/>
-          </a:prstGeom>
-          <a:noFill/>
-          <a:ln/>
-        </p:spPr>
-        <p:txBody>
-          <a:bodyPr wrap="square" rtlCol="0" anchor="ctr"/>
-          <a:lstStyle/>
-          <a:p>
-            <a:pPr algn="ctr" indent="0" marL="0">
-              <a:buNone/>
-            </a:pPr>
-            <a:r>
-              <a:rPr lang="en-US" sz="1600" i="1" dirty="0">
-                <a:solidFill>
-                  <a:srgbClr val="F4EFE6"/>
-                </a:solidFill>
-                <a:latin typeface="Georgia" pitchFamily="34" charset="0"/>
-                <a:ea typeface="Georgia" pitchFamily="34" charset="-122"/>
-                <a:cs typeface="Georgia" pitchFamily="34" charset="-120"/>
-              </a:rPr>
-              <a:t>Any chain in  →  Algorand out.</a:t>
+              <a:t>No bridge. No custodian. No seed phrase. The agent never holds an Algorand asset.</a:t>
             </a:r>
             <a:endParaRPr lang="en-US" sz="1600" dirty="0"/>
           </a:p>
@@ -2831,8 +2857,8 @@
         </p:nvSpPr>
         <p:spPr>
           <a:xfrm>
-            <a:off x="640080" y="502920"/>
-            <a:ext cx="10911535" cy="274320"/>
+            <a:off x="11277295" y="6355080"/>
+            <a:ext cx="548640" cy="274320"/>
           </a:xfrm>
           <a:prstGeom prst="rect">
             <a:avLst/>
@@ -2844,34 +2870,73 @@
           <a:bodyPr wrap="square" rtlCol="0" anchor="ctr"/>
           <a:lstStyle/>
           <a:p>
+            <a:pPr algn="r" indent="0" marL="0">
+              <a:buNone/>
+            </a:pPr>
+            <a:r>
+              <a:rPr lang="en-US" sz="900" dirty="0">
+                <a:solidFill>
+                  <a:srgbClr val="94A0B8"/>
+                </a:solidFill>
+                <a:latin typeface="Roboto Mono" pitchFamily="34" charset="0"/>
+                <a:ea typeface="Roboto Mono" pitchFamily="34" charset="-122"/>
+                <a:cs typeface="Roboto Mono" pitchFamily="34" charset="-120"/>
+              </a:rPr>
+              <a:t>05</a:t>
+            </a:r>
+            <a:endParaRPr lang="en-US" sz="900" dirty="0"/>
+          </a:p>
+        </p:txBody>
+      </p:sp>
+      <p:sp>
+        <p:nvSpPr>
+          <p:cNvPr id="3" name="Text 1"/>
+          <p:cNvSpPr/>
+          <p:nvPr/>
+        </p:nvSpPr>
+        <p:spPr>
+          <a:xfrm>
+            <a:off x="777240" y="566928"/>
+            <a:ext cx="10637215" cy="274320"/>
+          </a:xfrm>
+          <a:prstGeom prst="rect">
+            <a:avLst/>
+          </a:prstGeom>
+          <a:noFill/>
+          <a:ln/>
+        </p:spPr>
+        <p:txBody>
+          <a:bodyPr wrap="square" rtlCol="0" anchor="ctr"/>
+          <a:lstStyle/>
+          <a:p>
             <a:pPr indent="0" marL="0">
               <a:buNone/>
             </a:pPr>
             <a:r>
-              <a:rPr lang="en-US" sz="1200" b="1" spc="200" kern="0" dirty="0">
+              <a:rPr lang="en-US" sz="1100" spc="300" kern="0" dirty="0">
                 <a:solidFill>
                   <a:srgbClr val="D49A53"/>
                 </a:solidFill>
-                <a:latin typeface="Calibri" pitchFamily="34" charset="0"/>
-                <a:ea typeface="Calibri" pitchFamily="34" charset="-122"/>
-                <a:cs typeface="Calibri" pitchFamily="34" charset="-120"/>
+                <a:latin typeface="Roboto Mono" pitchFamily="34" charset="0"/>
+                <a:ea typeface="Roboto Mono" pitchFamily="34" charset="-122"/>
+                <a:cs typeface="Roboto Mono" pitchFamily="34" charset="-120"/>
               </a:rPr>
               <a:t>NOT A MOCKUP — MAINNET</a:t>
             </a:r>
-            <a:endParaRPr lang="en-US" sz="1200" dirty="0"/>
-          </a:p>
-        </p:txBody>
-      </p:sp>
-      <p:sp>
-        <p:nvSpPr>
-          <p:cNvPr id="3" name="Text 1"/>
-          <p:cNvSpPr/>
-          <p:nvPr/>
-        </p:nvSpPr>
-        <p:spPr>
-          <a:xfrm>
-            <a:off x="640080" y="868680"/>
-            <a:ext cx="10911535" cy="914400"/>
+            <a:endParaRPr lang="en-US" sz="1100" dirty="0"/>
+          </a:p>
+        </p:txBody>
+      </p:sp>
+      <p:sp>
+        <p:nvSpPr>
+          <p:cNvPr id="4" name="Text 2"/>
+          <p:cNvSpPr/>
+          <p:nvPr/>
+        </p:nvSpPr>
+        <p:spPr>
+          <a:xfrm>
+            <a:off x="777240" y="960120"/>
+            <a:ext cx="10637215" cy="868680"/>
           </a:xfrm>
           <a:prstGeom prst="rect">
             <a:avLst/>
@@ -2884,9 +2949,6 @@
           <a:lstStyle/>
           <a:p>
             <a:pPr indent="0" marL="0">
-              <a:lnSpc>
-                <a:spcPct val="100000"/>
-              </a:lnSpc>
               <a:buNone/>
             </a:pPr>
             <a:r>
@@ -2898,7 +2960,7 @@
                 <a:ea typeface="Georgia" pitchFamily="34" charset="-122"/>
                 <a:cs typeface="Georgia" pitchFamily="34" charset="-120"/>
               </a:rPr>
-              <a:t>Proven live on Algorand mainnet.</a:t>
+              <a:t>Proven live on Algorand.</a:t>
             </a:r>
             <a:endParaRPr lang="en-US" sz="3200" dirty="0"/>
           </a:p>
@@ -2919,155 +2981,17 @@
           </p:nvPr>
         </p:nvGraphicFramePr>
         <p:xfrm>
-          <a:off x="640080" y="2194560"/>
-          <a:ext cx="10911535" cy="914400"/>
+          <a:off x="777240" y="2148840"/>
+          <a:ext cx="10637215" cy="914400"/>
         </p:xfrm>
         <a:graphic>
           <a:graphicData uri="http://schemas.openxmlformats.org/drawingml/2006/table">
             <a:tbl>
               <a:tblPr/>
               <a:tblGrid>
-                <a:gridCol w="7680960"/>
-                <a:gridCol w="3230575"/>
+                <a:gridCol w="7315200"/>
+                <a:gridCol w="3322015"/>
               </a:tblGrid>
-              <a:tr h="457200">
-                <a:tc>
-                  <a:txBody>
-                    <a:bodyPr/>
-                    <a:lstStyle/>
-                    <a:p>
-                      <a:pPr indent="0" marL="0">
-                        <a:buNone/>
-                      </a:pPr>
-                      <a:r>
-                        <a:rPr lang="en-US" sz="1300" b="1" dirty="0">
-                          <a:solidFill>
-                            <a:srgbClr val="08102B"/>
-                          </a:solidFill>
-                          <a:latin typeface="Calibri" pitchFamily="34" charset="0"/>
-                          <a:ea typeface="Calibri" pitchFamily="34" charset="-122"/>
-                          <a:cs typeface="Calibri" pitchFamily="34" charset="-120"/>
-                        </a:rPr>
-                        <a:t>Proof</a:t>
-                      </a:r>
-                      <a:endParaRPr lang="en-US" sz="1300" dirty="0">
-                        <a:latin typeface="Calibri" charset="0"/>
-                        <a:ea typeface="Calibri" charset="0"/>
-                        <a:cs typeface="Calibri" charset="0"/>
-                      </a:endParaRPr>
-                    </a:p>
-                  </a:txBody>
-                  <a:tcPr marL="91440" marR="91440" marT="45720" marB="45720" anchor="ctr">
-                    <a:lnL w="12700" cap="flat" cmpd="sng" algn="ctr">
-                      <a:solidFill>
-                        <a:srgbClr val="142140"/>
-                      </a:solidFill>
-                      <a:prstDash val="solid"/>
-                      <a:round/>
-                      <a:headEnd type="none" w="med" len="med"/>
-                      <a:tailEnd type="none" w="med" len="med"/>
-                    </a:lnL>
-                    <a:lnR w="12700" cap="flat" cmpd="sng" algn="ctr">
-                      <a:solidFill>
-                        <a:srgbClr val="142140"/>
-                      </a:solidFill>
-                      <a:prstDash val="solid"/>
-                      <a:round/>
-                      <a:headEnd type="none" w="med" len="med"/>
-                      <a:tailEnd type="none" w="med" len="med"/>
-                    </a:lnR>
-                    <a:lnT w="12700" cap="flat" cmpd="sng" algn="ctr">
-                      <a:solidFill>
-                        <a:srgbClr val="142140"/>
-                      </a:solidFill>
-                      <a:prstDash val="solid"/>
-                      <a:round/>
-                      <a:headEnd type="none" w="med" len="med"/>
-                      <a:tailEnd type="none" w="med" len="med"/>
-                    </a:lnT>
-                    <a:lnB w="12700" cap="flat" cmpd="sng" algn="ctr">
-                      <a:solidFill>
-                        <a:srgbClr val="142140"/>
-                      </a:solidFill>
-                      <a:prstDash val="solid"/>
-                      <a:round/>
-                      <a:headEnd type="none" w="med" len="med"/>
-                      <a:tailEnd type="none" w="med" len="med"/>
-                    </a:lnB>
-                    <a:solidFill>
-                      <a:srgbClr val="D4A074"/>
-                    </a:solidFill>
-                  </a:tcPr>
-                </a:tc>
-                <a:tc>
-                  <a:txBody>
-                    <a:bodyPr/>
-                    <a:lstStyle/>
-                    <a:p>
-                      <a:pPr indent="0" marL="0">
-                        <a:buNone/>
-                      </a:pPr>
-                      <a:r>
-                        <a:rPr lang="en-US" sz="1300" b="1" dirty="0">
-                          <a:solidFill>
-                            <a:srgbClr val="08102B"/>
-                          </a:solidFill>
-                          <a:latin typeface="Calibri" pitchFamily="34" charset="0"/>
-                          <a:ea typeface="Calibri" pitchFamily="34" charset="-122"/>
-                          <a:cs typeface="Calibri" pitchFamily="34" charset="-120"/>
-                        </a:rPr>
-                        <a:t>Mainnet transaction</a:t>
-                      </a:r>
-                      <a:endParaRPr lang="en-US" sz="1300" dirty="0">
-                        <a:latin typeface="Calibri" charset="0"/>
-                        <a:ea typeface="Calibri" charset="0"/>
-                        <a:cs typeface="Calibri" charset="0"/>
-                      </a:endParaRPr>
-                    </a:p>
-                  </a:txBody>
-                  <a:tcPr marL="91440" marR="91440" marT="45720" marB="45720" anchor="ctr">
-                    <a:lnL w="12700" cap="flat" cmpd="sng" algn="ctr">
-                      <a:solidFill>
-                        <a:srgbClr val="142140"/>
-                      </a:solidFill>
-                      <a:prstDash val="solid"/>
-                      <a:round/>
-                      <a:headEnd type="none" w="med" len="med"/>
-                      <a:tailEnd type="none" w="med" len="med"/>
-                    </a:lnL>
-                    <a:lnR w="12700" cap="flat" cmpd="sng" algn="ctr">
-                      <a:solidFill>
-                        <a:srgbClr val="142140"/>
-                      </a:solidFill>
-                      <a:prstDash val="solid"/>
-                      <a:round/>
-                      <a:headEnd type="none" w="med" len="med"/>
-                      <a:tailEnd type="none" w="med" len="med"/>
-                    </a:lnR>
-                    <a:lnT w="12700" cap="flat" cmpd="sng" algn="ctr">
-                      <a:solidFill>
-                        <a:srgbClr val="142140"/>
-                      </a:solidFill>
-                      <a:prstDash val="solid"/>
-                      <a:round/>
-                      <a:headEnd type="none" w="med" len="med"/>
-                      <a:tailEnd type="none" w="med" len="med"/>
-                    </a:lnT>
-                    <a:lnB w="12700" cap="flat" cmpd="sng" algn="ctr">
-                      <a:solidFill>
-                        <a:srgbClr val="142140"/>
-                      </a:solidFill>
-                      <a:prstDash val="solid"/>
-                      <a:round/>
-                      <a:headEnd type="none" w="med" len="med"/>
-                      <a:tailEnd type="none" w="med" len="med"/>
-                    </a:lnB>
-                    <a:solidFill>
-                      <a:srgbClr val="D4A074"/>
-                    </a:solidFill>
-                  </a:tcPr>
-                </a:tc>
-              </a:tr>
               <a:tr h="868680">
                 <a:tc>
                   <a:txBody>
@@ -3078,7 +3002,7 @@
                         <a:buNone/>
                       </a:pPr>
                       <a:r>
-                        <a:rPr lang="en-US" sz="1400" dirty="0">
+                        <a:rPr lang="en-US" sz="1500" dirty="0">
                           <a:solidFill>
                             <a:srgbClr val="F4EFE6"/>
                           </a:solidFill>
@@ -3086,51 +3010,33 @@
                           <a:ea typeface="Calibri" pitchFamily="34" charset="-122"/>
                           <a:cs typeface="Calibri" pitchFamily="34" charset="-120"/>
                         </a:rPr>
-                        <a:t>Threshold-paid a REAL third-party Algorand x402 service (Carbon &amp; Cashmere) — returned a live result</a:t>
+                        <a:t>Threshold-paid a REAL third-party Algorand x402 service (Carbon &amp; Cashmere)</a:t>
                       </a:r>
-                      <a:endParaRPr lang="en-US" sz="1400" dirty="0">
+                      <a:endParaRPr lang="en-US" sz="1500" dirty="0">
                         <a:latin typeface="Calibri" charset="0"/>
                         <a:ea typeface="Calibri" charset="0"/>
                         <a:cs typeface="Calibri" charset="0"/>
                       </a:endParaRPr>
                     </a:p>
                   </a:txBody>
-                  <a:tcPr marL="91440" marR="91440" marT="45720" marB="45720" anchor="ctr">
-                    <a:lnL w="12700" cap="flat" cmpd="sng" algn="ctr">
+                  <a:tcPr marL="127000" marR="127000" marT="76200" marB="76200" anchor="ctr">
+                    <a:lnL w="0" cap="flat" cmpd="sng" algn="ctr">
+                      <a:noFill/>
+                    </a:lnL>
+                    <a:lnR w="0" cap="flat" cmpd="sng" algn="ctr">
+                      <a:noFill/>
+                    </a:lnR>
+                    <a:lnT w="38100" cap="flat" cmpd="sng" algn="ctr">
                       <a:solidFill>
-                        <a:srgbClr val="142140"/>
-                      </a:solidFill>
-                      <a:prstDash val="solid"/>
-                      <a:round/>
-                      <a:headEnd type="none" w="med" len="med"/>
-                      <a:tailEnd type="none" w="med" len="med"/>
-                    </a:lnL>
-                    <a:lnR w="12700" cap="flat" cmpd="sng" algn="ctr">
-                      <a:solidFill>
-                        <a:srgbClr val="142140"/>
-                      </a:solidFill>
-                      <a:prstDash val="solid"/>
-                      <a:round/>
-                      <a:headEnd type="none" w="med" len="med"/>
-                      <a:tailEnd type="none" w="med" len="med"/>
-                    </a:lnR>
-                    <a:lnT w="12700" cap="flat" cmpd="sng" algn="ctr">
-                      <a:solidFill>
-                        <a:srgbClr val="142140"/>
+                        <a:srgbClr val="08102B"/>
                       </a:solidFill>
                       <a:prstDash val="solid"/>
                       <a:round/>
                       <a:headEnd type="none" w="med" len="med"/>
                       <a:tailEnd type="none" w="med" len="med"/>
                     </a:lnT>
-                    <a:lnB w="12700" cap="flat" cmpd="sng" algn="ctr">
-                      <a:solidFill>
-                        <a:srgbClr val="142140"/>
-                      </a:solidFill>
-                      <a:prstDash val="solid"/>
-                      <a:round/>
-                      <a:headEnd type="none" w="med" len="med"/>
-                      <a:tailEnd type="none" w="med" len="med"/>
+                    <a:lnB w="0" cap="flat" cmpd="sng" algn="ctr">
+                      <a:noFill/>
                     </a:lnB>
                     <a:solidFill>
                       <a:srgbClr val="0E1A38"/>
@@ -3142,63 +3048,45 @@
                     <a:bodyPr/>
                     <a:lstStyle/>
                     <a:p>
-                      <a:pPr indent="0" marL="0">
+                      <a:pPr algn="ctr" indent="0" marL="0">
                         <a:buNone/>
                       </a:pPr>
                       <a:r>
-                        <a:rPr lang="en-US" sz="1400" dirty="0">
+                        <a:rPr lang="en-US" sz="1500" dirty="0">
                           <a:solidFill>
                             <a:srgbClr val="4CB06E"/>
                           </a:solidFill>
-                          <a:latin typeface="Consolas" pitchFamily="34" charset="0"/>
-                          <a:ea typeface="Consolas" pitchFamily="34" charset="-122"/>
-                          <a:cs typeface="Consolas" pitchFamily="34" charset="-120"/>
+                          <a:latin typeface="Roboto Mono" pitchFamily="34" charset="0"/>
+                          <a:ea typeface="Roboto Mono" pitchFamily="34" charset="-122"/>
+                          <a:cs typeface="Roboto Mono" pitchFamily="34" charset="-120"/>
                         </a:rPr>
                         <a:t>RKGSX6MB…WH4EAA</a:t>
                       </a:r>
-                      <a:endParaRPr lang="en-US" sz="1400" dirty="0">
-                        <a:latin typeface="Consolas" charset="0"/>
-                        <a:ea typeface="Consolas" charset="0"/>
-                        <a:cs typeface="Consolas" charset="0"/>
+                      <a:endParaRPr lang="en-US" sz="1500" dirty="0">
+                        <a:latin typeface="Roboto Mono" charset="0"/>
+                        <a:ea typeface="Roboto Mono" charset="0"/>
+                        <a:cs typeface="Roboto Mono" charset="0"/>
                       </a:endParaRPr>
                     </a:p>
                   </a:txBody>
-                  <a:tcPr marL="91440" marR="91440" marT="45720" marB="45720" anchor="ctr">
-                    <a:lnL w="12700" cap="flat" cmpd="sng" algn="ctr">
+                  <a:tcPr marL="127000" marR="127000" marT="76200" marB="76200" anchor="ctr">
+                    <a:lnL w="0" cap="flat" cmpd="sng" algn="ctr">
+                      <a:noFill/>
+                    </a:lnL>
+                    <a:lnR w="0" cap="flat" cmpd="sng" algn="ctr">
+                      <a:noFill/>
+                    </a:lnR>
+                    <a:lnT w="38100" cap="flat" cmpd="sng" algn="ctr">
                       <a:solidFill>
-                        <a:srgbClr val="142140"/>
-                      </a:solidFill>
-                      <a:prstDash val="solid"/>
-                      <a:round/>
-                      <a:headEnd type="none" w="med" len="med"/>
-                      <a:tailEnd type="none" w="med" len="med"/>
-                    </a:lnL>
-                    <a:lnR w="12700" cap="flat" cmpd="sng" algn="ctr">
-                      <a:solidFill>
-                        <a:srgbClr val="142140"/>
-                      </a:solidFill>
-                      <a:prstDash val="solid"/>
-                      <a:round/>
-                      <a:headEnd type="none" w="med" len="med"/>
-                      <a:tailEnd type="none" w="med" len="med"/>
-                    </a:lnR>
-                    <a:lnT w="12700" cap="flat" cmpd="sng" algn="ctr">
-                      <a:solidFill>
-                        <a:srgbClr val="142140"/>
+                        <a:srgbClr val="08102B"/>
                       </a:solidFill>
                       <a:prstDash val="solid"/>
                       <a:round/>
                       <a:headEnd type="none" w="med" len="med"/>
                       <a:tailEnd type="none" w="med" len="med"/>
                     </a:lnT>
-                    <a:lnB w="12700" cap="flat" cmpd="sng" algn="ctr">
-                      <a:solidFill>
-                        <a:srgbClr val="142140"/>
-                      </a:solidFill>
-                      <a:prstDash val="solid"/>
-                      <a:round/>
-                      <a:headEnd type="none" w="med" len="med"/>
-                      <a:tailEnd type="none" w="med" len="med"/>
+                    <a:lnB w="0" cap="flat" cmpd="sng" algn="ctr">
+                      <a:noFill/>
                     </a:lnB>
                     <a:solidFill>
                       <a:srgbClr val="0E1A38"/>
@@ -3206,7 +3094,7 @@
                   </a:tcPr>
                 </a:tc>
               </a:tr>
-              <a:tr h="640080">
+              <a:tr h="731520">
                 <a:tc>
                   <a:txBody>
                     <a:bodyPr/>
@@ -3216,7 +3104,7 @@
                         <a:buNone/>
                       </a:pPr>
                       <a:r>
-                        <a:rPr lang="en-US" sz="1400" dirty="0">
+                        <a:rPr lang="en-US" sz="1500" dirty="0">
                           <a:solidFill>
                             <a:srgbClr val="F4EFE6"/>
                           </a:solidFill>
@@ -3224,51 +3112,33 @@
                           <a:ea typeface="Calibri" pitchFamily="34" charset="-122"/>
                           <a:cs typeface="Calibri" pitchFamily="34" charset="-120"/>
                         </a:rPr>
-                        <a:t>Threshold-paid our own AI inference endpoint (Featherless)</a:t>
+                        <a:t>Threshold-paid our own Algorand x402 AI endpoint</a:t>
                       </a:r>
-                      <a:endParaRPr lang="en-US" sz="1400" dirty="0">
+                      <a:endParaRPr lang="en-US" sz="1500" dirty="0">
                         <a:latin typeface="Calibri" charset="0"/>
                         <a:ea typeface="Calibri" charset="0"/>
                         <a:cs typeface="Calibri" charset="0"/>
                       </a:endParaRPr>
                     </a:p>
                   </a:txBody>
-                  <a:tcPr marL="91440" marR="91440" marT="45720" marB="45720" anchor="ctr">
-                    <a:lnL w="12700" cap="flat" cmpd="sng" algn="ctr">
+                  <a:tcPr marL="127000" marR="127000" marT="76200" marB="76200" anchor="ctr">
+                    <a:lnL w="0" cap="flat" cmpd="sng" algn="ctr">
+                      <a:noFill/>
+                    </a:lnL>
+                    <a:lnR w="0" cap="flat" cmpd="sng" algn="ctr">
+                      <a:noFill/>
+                    </a:lnR>
+                    <a:lnT w="38100" cap="flat" cmpd="sng" algn="ctr">
                       <a:solidFill>
-                        <a:srgbClr val="142140"/>
-                      </a:solidFill>
-                      <a:prstDash val="solid"/>
-                      <a:round/>
-                      <a:headEnd type="none" w="med" len="med"/>
-                      <a:tailEnd type="none" w="med" len="med"/>
-                    </a:lnL>
-                    <a:lnR w="12700" cap="flat" cmpd="sng" algn="ctr">
-                      <a:solidFill>
-                        <a:srgbClr val="142140"/>
-                      </a:solidFill>
-                      <a:prstDash val="solid"/>
-                      <a:round/>
-                      <a:headEnd type="none" w="med" len="med"/>
-                      <a:tailEnd type="none" w="med" len="med"/>
-                    </a:lnR>
-                    <a:lnT w="12700" cap="flat" cmpd="sng" algn="ctr">
-                      <a:solidFill>
-                        <a:srgbClr val="142140"/>
+                        <a:srgbClr val="08102B"/>
                       </a:solidFill>
                       <a:prstDash val="solid"/>
                       <a:round/>
                       <a:headEnd type="none" w="med" len="med"/>
                       <a:tailEnd type="none" w="med" len="med"/>
                     </a:lnT>
-                    <a:lnB w="12700" cap="flat" cmpd="sng" algn="ctr">
-                      <a:solidFill>
-                        <a:srgbClr val="142140"/>
-                      </a:solidFill>
-                      <a:prstDash val="solid"/>
-                      <a:round/>
-                      <a:headEnd type="none" w="med" len="med"/>
-                      <a:tailEnd type="none" w="med" len="med"/>
+                    <a:lnB w="0" cap="flat" cmpd="sng" algn="ctr">
+                      <a:noFill/>
                     </a:lnB>
                     <a:solidFill>
                       <a:srgbClr val="0E1A38"/>
@@ -3280,63 +3150,45 @@
                     <a:bodyPr/>
                     <a:lstStyle/>
                     <a:p>
-                      <a:pPr indent="0" marL="0">
+                      <a:pPr algn="ctr" indent="0" marL="0">
                         <a:buNone/>
                       </a:pPr>
                       <a:r>
-                        <a:rPr lang="en-US" sz="1400" dirty="0">
+                        <a:rPr lang="en-US" sz="1500" dirty="0">
                           <a:solidFill>
                             <a:srgbClr val="4CB06E"/>
                           </a:solidFill>
-                          <a:latin typeface="Consolas" pitchFamily="34" charset="0"/>
-                          <a:ea typeface="Consolas" pitchFamily="34" charset="-122"/>
-                          <a:cs typeface="Consolas" pitchFamily="34" charset="-120"/>
+                          <a:latin typeface="Roboto Mono" pitchFamily="34" charset="0"/>
+                          <a:ea typeface="Roboto Mono" pitchFamily="34" charset="-122"/>
+                          <a:cs typeface="Roboto Mono" pitchFamily="34" charset="-120"/>
                         </a:rPr>
                         <a:t>35EJIH6M…RF2Q</a:t>
                       </a:r>
-                      <a:endParaRPr lang="en-US" sz="1400" dirty="0">
-                        <a:latin typeface="Consolas" charset="0"/>
-                        <a:ea typeface="Consolas" charset="0"/>
-                        <a:cs typeface="Consolas" charset="0"/>
+                      <a:endParaRPr lang="en-US" sz="1500" dirty="0">
+                        <a:latin typeface="Roboto Mono" charset="0"/>
+                        <a:ea typeface="Roboto Mono" charset="0"/>
+                        <a:cs typeface="Roboto Mono" charset="0"/>
                       </a:endParaRPr>
                     </a:p>
                   </a:txBody>
-                  <a:tcPr marL="91440" marR="91440" marT="45720" marB="45720" anchor="ctr">
-                    <a:lnL w="12700" cap="flat" cmpd="sng" algn="ctr">
+                  <a:tcPr marL="127000" marR="127000" marT="76200" marB="76200" anchor="ctr">
+                    <a:lnL w="0" cap="flat" cmpd="sng" algn="ctr">
+                      <a:noFill/>
+                    </a:lnL>
+                    <a:lnR w="0" cap="flat" cmpd="sng" algn="ctr">
+                      <a:noFill/>
+                    </a:lnR>
+                    <a:lnT w="38100" cap="flat" cmpd="sng" algn="ctr">
                       <a:solidFill>
-                        <a:srgbClr val="142140"/>
-                      </a:solidFill>
-                      <a:prstDash val="solid"/>
-                      <a:round/>
-                      <a:headEnd type="none" w="med" len="med"/>
-                      <a:tailEnd type="none" w="med" len="med"/>
-                    </a:lnL>
-                    <a:lnR w="12700" cap="flat" cmpd="sng" algn="ctr">
-                      <a:solidFill>
-                        <a:srgbClr val="142140"/>
-                      </a:solidFill>
-                      <a:prstDash val="solid"/>
-                      <a:round/>
-                      <a:headEnd type="none" w="med" len="med"/>
-                      <a:tailEnd type="none" w="med" len="med"/>
-                    </a:lnR>
-                    <a:lnT w="12700" cap="flat" cmpd="sng" algn="ctr">
-                      <a:solidFill>
-                        <a:srgbClr val="142140"/>
+                        <a:srgbClr val="08102B"/>
                       </a:solidFill>
                       <a:prstDash val="solid"/>
                       <a:round/>
                       <a:headEnd type="none" w="med" len="med"/>
                       <a:tailEnd type="none" w="med" len="med"/>
                     </a:lnT>
-                    <a:lnB w="12700" cap="flat" cmpd="sng" algn="ctr">
-                      <a:solidFill>
-                        <a:srgbClr val="142140"/>
-                      </a:solidFill>
-                      <a:prstDash val="solid"/>
-                      <a:round/>
-                      <a:headEnd type="none" w="med" len="med"/>
-                      <a:tailEnd type="none" w="med" len="med"/>
+                    <a:lnB w="0" cap="flat" cmpd="sng" algn="ctr">
+                      <a:noFill/>
                     </a:lnB>
                     <a:solidFill>
                       <a:srgbClr val="0E1A38"/>
@@ -3354,7 +3206,7 @@
                         <a:buNone/>
                       </a:pPr>
                       <a:r>
-                        <a:rPr lang="en-US" sz="1400" dirty="0">
+                        <a:rPr lang="en-US" sz="1500" dirty="0">
                           <a:solidFill>
                             <a:srgbClr val="F4EFE6"/>
                           </a:solidFill>
@@ -3362,51 +3214,33 @@
                           <a:ea typeface="Calibri" pitchFamily="34" charset="-122"/>
                           <a:cs typeface="Calibri" pitchFamily="34" charset="-120"/>
                         </a:rPr>
-                        <a:t>Quantoz EURQ wired + settlement reserve opted into the EURQ ASA (bonus)</a:t>
+                        <a:t>Quantoz EURQ wired + settlement reserve opted into the EURQ ASA</a:t>
                       </a:r>
-                      <a:endParaRPr lang="en-US" sz="1400" dirty="0">
+                      <a:endParaRPr lang="en-US" sz="1500" dirty="0">
                         <a:latin typeface="Calibri" charset="0"/>
                         <a:ea typeface="Calibri" charset="0"/>
                         <a:cs typeface="Calibri" charset="0"/>
                       </a:endParaRPr>
                     </a:p>
                   </a:txBody>
-                  <a:tcPr marL="91440" marR="91440" marT="45720" marB="45720" anchor="ctr">
-                    <a:lnL w="12700" cap="flat" cmpd="sng" algn="ctr">
+                  <a:tcPr marL="127000" marR="127000" marT="76200" marB="76200" anchor="ctr">
+                    <a:lnL w="0" cap="flat" cmpd="sng" algn="ctr">
+                      <a:noFill/>
+                    </a:lnL>
+                    <a:lnR w="0" cap="flat" cmpd="sng" algn="ctr">
+                      <a:noFill/>
+                    </a:lnR>
+                    <a:lnT w="38100" cap="flat" cmpd="sng" algn="ctr">
                       <a:solidFill>
-                        <a:srgbClr val="142140"/>
-                      </a:solidFill>
-                      <a:prstDash val="solid"/>
-                      <a:round/>
-                      <a:headEnd type="none" w="med" len="med"/>
-                      <a:tailEnd type="none" w="med" len="med"/>
-                    </a:lnL>
-                    <a:lnR w="12700" cap="flat" cmpd="sng" algn="ctr">
-                      <a:solidFill>
-                        <a:srgbClr val="142140"/>
-                      </a:solidFill>
-                      <a:prstDash val="solid"/>
-                      <a:round/>
-                      <a:headEnd type="none" w="med" len="med"/>
-                      <a:tailEnd type="none" w="med" len="med"/>
-                    </a:lnR>
-                    <a:lnT w="12700" cap="flat" cmpd="sng" algn="ctr">
-                      <a:solidFill>
-                        <a:srgbClr val="142140"/>
+                        <a:srgbClr val="08102B"/>
                       </a:solidFill>
                       <a:prstDash val="solid"/>
                       <a:round/>
                       <a:headEnd type="none" w="med" len="med"/>
                       <a:tailEnd type="none" w="med" len="med"/>
                     </a:lnT>
-                    <a:lnB w="12700" cap="flat" cmpd="sng" algn="ctr">
-                      <a:solidFill>
-                        <a:srgbClr val="142140"/>
-                      </a:solidFill>
-                      <a:prstDash val="solid"/>
-                      <a:round/>
-                      <a:headEnd type="none" w="med" len="med"/>
-                      <a:tailEnd type="none" w="med" len="med"/>
+                    <a:lnB w="0" cap="flat" cmpd="sng" algn="ctr">
+                      <a:noFill/>
                     </a:lnB>
                     <a:solidFill>
                       <a:srgbClr val="0E1A38"/>
@@ -3418,63 +3252,45 @@
                     <a:bodyPr/>
                     <a:lstStyle/>
                     <a:p>
-                      <a:pPr indent="0" marL="0">
+                      <a:pPr algn="ctr" indent="0" marL="0">
                         <a:buNone/>
                       </a:pPr>
                       <a:r>
-                        <a:rPr lang="en-US" sz="1400" dirty="0">
+                        <a:rPr lang="en-US" sz="1500" dirty="0">
                           <a:solidFill>
                             <a:srgbClr val="4CB06E"/>
                           </a:solidFill>
-                          <a:latin typeface="Consolas" pitchFamily="34" charset="0"/>
-                          <a:ea typeface="Consolas" pitchFamily="34" charset="-122"/>
-                          <a:cs typeface="Consolas" pitchFamily="34" charset="-120"/>
+                          <a:latin typeface="Roboto Mono" pitchFamily="34" charset="0"/>
+                          <a:ea typeface="Roboto Mono" pitchFamily="34" charset="-122"/>
+                          <a:cs typeface="Roboto Mono" pitchFamily="34" charset="-120"/>
                         </a:rPr>
                         <a:t>KGL55F3I…74Q2QA</a:t>
                       </a:r>
-                      <a:endParaRPr lang="en-US" sz="1400" dirty="0">
-                        <a:latin typeface="Consolas" charset="0"/>
-                        <a:ea typeface="Consolas" charset="0"/>
-                        <a:cs typeface="Consolas" charset="0"/>
+                      <a:endParaRPr lang="en-US" sz="1500" dirty="0">
+                        <a:latin typeface="Roboto Mono" charset="0"/>
+                        <a:ea typeface="Roboto Mono" charset="0"/>
+                        <a:cs typeface="Roboto Mono" charset="0"/>
                       </a:endParaRPr>
                     </a:p>
                   </a:txBody>
-                  <a:tcPr marL="91440" marR="91440" marT="45720" marB="45720" anchor="ctr">
-                    <a:lnL w="12700" cap="flat" cmpd="sng" algn="ctr">
+                  <a:tcPr marL="127000" marR="127000" marT="76200" marB="76200" anchor="ctr">
+                    <a:lnL w="0" cap="flat" cmpd="sng" algn="ctr">
+                      <a:noFill/>
+                    </a:lnL>
+                    <a:lnR w="0" cap="flat" cmpd="sng" algn="ctr">
+                      <a:noFill/>
+                    </a:lnR>
+                    <a:lnT w="38100" cap="flat" cmpd="sng" algn="ctr">
                       <a:solidFill>
-                        <a:srgbClr val="142140"/>
-                      </a:solidFill>
-                      <a:prstDash val="solid"/>
-                      <a:round/>
-                      <a:headEnd type="none" w="med" len="med"/>
-                      <a:tailEnd type="none" w="med" len="med"/>
-                    </a:lnL>
-                    <a:lnR w="12700" cap="flat" cmpd="sng" algn="ctr">
-                      <a:solidFill>
-                        <a:srgbClr val="142140"/>
-                      </a:solidFill>
-                      <a:prstDash val="solid"/>
-                      <a:round/>
-                      <a:headEnd type="none" w="med" len="med"/>
-                      <a:tailEnd type="none" w="med" len="med"/>
-                    </a:lnR>
-                    <a:lnT w="12700" cap="flat" cmpd="sng" algn="ctr">
-                      <a:solidFill>
-                        <a:srgbClr val="142140"/>
+                        <a:srgbClr val="08102B"/>
                       </a:solidFill>
                       <a:prstDash val="solid"/>
                       <a:round/>
                       <a:headEnd type="none" w="med" len="med"/>
                       <a:tailEnd type="none" w="med" len="med"/>
                     </a:lnT>
-                    <a:lnB w="12700" cap="flat" cmpd="sng" algn="ctr">
-                      <a:solidFill>
-                        <a:srgbClr val="142140"/>
-                      </a:solidFill>
-                      <a:prstDash val="solid"/>
-                      <a:round/>
-                      <a:headEnd type="none" w="med" len="med"/>
-                      <a:tailEnd type="none" w="med" len="med"/>
+                    <a:lnB w="0" cap="flat" cmpd="sng" algn="ctr">
+                      <a:noFill/>
                     </a:lnB>
                     <a:solidFill>
                       <a:srgbClr val="0E1A38"/>
@@ -3488,14 +3304,14 @@
       </p:graphicFrame>
       <p:sp>
         <p:nvSpPr>
-          <p:cNvPr id="5" name="Text 2"/>
-          <p:cNvSpPr/>
-          <p:nvPr/>
-        </p:nvSpPr>
-        <p:spPr>
-          <a:xfrm>
-            <a:off x="640080" y="5897880"/>
-            <a:ext cx="10911535" cy="457200"/>
+          <p:cNvPr id="6" name="Text 3"/>
+          <p:cNvSpPr/>
+          <p:nvPr/>
+        </p:nvSpPr>
+        <p:spPr>
+          <a:xfrm>
+            <a:off x="777240" y="5486400"/>
+            <a:ext cx="10637215" cy="457200"/>
           </a:xfrm>
           <a:prstGeom prst="rect">
             <a:avLst/>
@@ -3508,9 +3324,6 @@
           <a:lstStyle/>
           <a:p>
             <a:pPr indent="0" marL="0">
-              <a:lnSpc>
-                <a:spcPct val="110000"/>
-              </a:lnSpc>
               <a:buNone/>
             </a:pPr>
             <a:r>
@@ -3522,7 +3335,7 @@
                 <a:ea typeface="Calibri" pitchFamily="34" charset="-122"/>
                 <a:cs typeface="Calibri" pitchFamily="34" charset="-120"/>
               </a:rPr>
-              <a:t>First VERIFIED Algorand x402 service on the Sippar Marketplace  ·  endpoint accepts USDC + Quantoz EURQ  ·  4 production ICP canisters  ·  x402 live on 10 chains.</a:t>
+              <a:t>First verified Algorand x402 service on the Sippar Marketplace · accepts USDC + EURQ · 4 ICP canisters · x402 on 10 chains.</a:t>
             </a:r>
             <a:endParaRPr lang="en-US" sz="1250" dirty="0"/>
           </a:p>
@@ -3568,8 +3381,8 @@
         </p:nvSpPr>
         <p:spPr>
           <a:xfrm>
-            <a:off x="640080" y="1554480"/>
-            <a:ext cx="10911535" cy="1463040"/>
+            <a:off x="777240" y="1691640"/>
+            <a:ext cx="10637215" cy="1554480"/>
           </a:xfrm>
           <a:prstGeom prst="rect">
             <a:avLst/>
@@ -3588,7 +3401,7 @@
               <a:buNone/>
             </a:pPr>
             <a:r>
-              <a:rPr lang="en-US" sz="3400" b="1" dirty="0">
+              <a:rPr lang="en-US" sz="3600" b="1" dirty="0">
                 <a:solidFill>
                   <a:srgbClr val="D4A074"/>
                 </a:solidFill>
@@ -3598,7 +3411,7 @@
               </a:rPr>
               <a:t>Banks settle between banks.</a:t>
             </a:r>
-            <a:endParaRPr lang="en-US" sz="3400" dirty="0"/>
+            <a:endParaRPr lang="en-US" sz="3600" dirty="0"/>
           </a:p>
           <a:p>
             <a:pPr indent="0" marL="0">
@@ -3608,7 +3421,7 @@
               <a:buNone/>
             </a:pPr>
             <a:r>
-              <a:rPr lang="en-US" sz="3400" b="1" dirty="0">
+              <a:rPr lang="en-US" sz="3600" b="1" dirty="0">
                 <a:solidFill>
                   <a:srgbClr val="D4A074"/>
                 </a:solidFill>
@@ -3618,7 +3431,7 @@
               </a:rPr>
               <a:t>Agents settle between agents.</a:t>
             </a:r>
-            <a:endParaRPr lang="en-US" sz="3400" dirty="0"/>
+            <a:endParaRPr lang="en-US" sz="3600" dirty="0"/>
           </a:p>
         </p:txBody>
       </p:sp>
@@ -3630,8 +3443,8 @@
         </p:nvSpPr>
         <p:spPr>
           <a:xfrm>
-            <a:off x="640080" y="3200400"/>
-            <a:ext cx="10911535" cy="822960"/>
+            <a:off x="777240" y="3429000"/>
+            <a:ext cx="10637215" cy="640080"/>
           </a:xfrm>
           <a:prstGeom prst="rect">
             <a:avLst/>
@@ -3644,13 +3457,10 @@
           <a:lstStyle/>
           <a:p>
             <a:pPr indent="0" marL="0">
-              <a:lnSpc>
-                <a:spcPct val="120000"/>
-              </a:lnSpc>
               <a:buNone/>
             </a:pPr>
             <a:r>
-              <a:rPr lang="en-US" sz="1700" dirty="0">
+              <a:rPr lang="en-US" sz="1800" dirty="0">
                 <a:solidFill>
                   <a:srgbClr val="F4EFE6"/>
                 </a:solidFill>
@@ -3658,9 +3468,9 @@
                 <a:ea typeface="Calibri" pitchFamily="34" charset="-122"/>
                 <a:cs typeface="Calibri" pitchFamily="34" charset="-120"/>
               </a:rPr>
-              <a:t>Sippar makes Algorand the settlement hub for every agent, on any chain — live on mainnet today.</a:t>
-            </a:r>
-            <a:endParaRPr lang="en-US" sz="1700" dirty="0"/>
+              <a:t>Sippar makes Algorand the settlement hub for every agent — live on mainnet today.</a:t>
+            </a:r>
+            <a:endParaRPr lang="en-US" sz="1800" dirty="0"/>
           </a:p>
         </p:txBody>
       </p:sp>
@@ -3672,8 +3482,8 @@
         </p:nvSpPr>
         <p:spPr>
           <a:xfrm>
-            <a:off x="640080" y="4114800"/>
-            <a:ext cx="10911535" cy="548640"/>
+            <a:off x="777240" y="4572000"/>
+            <a:ext cx="10637215" cy="457200"/>
           </a:xfrm>
           <a:prstGeom prst="rect">
             <a:avLst/>
@@ -3689,17 +3499,17 @@
               <a:buNone/>
             </a:pPr>
             <a:r>
-              <a:rPr lang="en-US" sz="1400" i="1" dirty="0">
-                <a:solidFill>
-                  <a:srgbClr val="94A0B8"/>
+              <a:rPr lang="en-US" sz="2000" b="1" dirty="0">
+                <a:solidFill>
+                  <a:srgbClr val="D4A074"/>
                 </a:solidFill>
                 <a:latin typeface="Georgia" pitchFamily="34" charset="0"/>
                 <a:ea typeface="Georgia" pitchFamily="34" charset="-122"/>
                 <a:cs typeface="Georgia" pitchFamily="34" charset="-120"/>
               </a:rPr>
-              <a:t>Named for the ancient city of justice and verification — the first cross-chain payment map, 4,000 years on.</a:t>
-            </a:r>
-            <a:endParaRPr lang="en-US" sz="1400" dirty="0"/>
+              <a:t>Give an agent a budget. Watch what it buys.</a:t>
+            </a:r>
+            <a:endParaRPr lang="en-US" sz="2000" dirty="0"/>
           </a:p>
         </p:txBody>
       </p:sp>
@@ -3711,8 +3521,8 @@
         </p:nvSpPr>
         <p:spPr>
           <a:xfrm>
-            <a:off x="640080" y="5120640"/>
-            <a:ext cx="10911535" cy="457200"/>
+            <a:off x="777240" y="6035040"/>
+            <a:ext cx="10637215" cy="320040"/>
           </a:xfrm>
           <a:prstGeom prst="rect">
             <a:avLst/>
@@ -3728,56 +3538,17 @@
               <a:buNone/>
             </a:pPr>
             <a:r>
-              <a:rPr lang="en-US" sz="1800" b="1" dirty="0">
-                <a:solidFill>
-                  <a:srgbClr val="D4A074"/>
-                </a:solidFill>
-                <a:latin typeface="Georgia" pitchFamily="34" charset="0"/>
-                <a:ea typeface="Georgia" pitchFamily="34" charset="-122"/>
-                <a:cs typeface="Georgia" pitchFamily="34" charset="-120"/>
-              </a:rPr>
-              <a:t>Give an agent a budget. Watch what it buys.</a:t>
-            </a:r>
-            <a:endParaRPr lang="en-US" sz="1800" dirty="0"/>
-          </a:p>
-        </p:txBody>
-      </p:sp>
-      <p:sp>
-        <p:nvSpPr>
-          <p:cNvPr id="6" name="Text 4"/>
-          <p:cNvSpPr/>
-          <p:nvPr/>
-        </p:nvSpPr>
-        <p:spPr>
-          <a:xfrm>
-            <a:off x="640080" y="6126480"/>
-            <a:ext cx="10911535" cy="365760"/>
-          </a:xfrm>
-          <a:prstGeom prst="rect">
-            <a:avLst/>
-          </a:prstGeom>
-          <a:noFill/>
-          <a:ln/>
-        </p:spPr>
-        <p:txBody>
-          <a:bodyPr wrap="square" rtlCol="0" anchor="ctr"/>
-          <a:lstStyle/>
-          <a:p>
-            <a:pPr indent="0" marL="0">
-              <a:buNone/>
-            </a:pPr>
-            <a:r>
-              <a:rPr lang="en-US" sz="1300" dirty="0">
+              <a:rPr lang="en-US" sz="1200" dirty="0">
                 <a:solidFill>
                   <a:srgbClr val="D49A53"/>
                 </a:solidFill>
-                <a:latin typeface="Calibri" pitchFamily="34" charset="0"/>
-                <a:ea typeface="Calibri" pitchFamily="34" charset="-122"/>
-                <a:cs typeface="Calibri" pitchFamily="34" charset="-120"/>
-              </a:rPr>
-              <a:t>github.com/Nuru-AI/sippar-algorand-x402     ·     sippar.network</a:t>
-            </a:r>
-            <a:endParaRPr lang="en-US" sz="1300" dirty="0"/>
+                <a:latin typeface="Roboto Mono" pitchFamily="34" charset="0"/>
+                <a:ea typeface="Roboto Mono" pitchFamily="34" charset="-122"/>
+                <a:cs typeface="Roboto Mono" pitchFamily="34" charset="-120"/>
+              </a:rPr>
+              <a:t>github.com/Nuru-AI/sippar-algorand-x402          sippar.network</a:t>
+            </a:r>
+            <a:endParaRPr lang="en-US" sz="1200" dirty="0"/>
           </a:p>
         </p:txBody>
       </p:sp>

</xml_diff>